<commit_message>
Major upgrade: professional tool, 10 test files, detailed docs, themed presentation
</commit_message>
<xml_diff>
--- a/CAN_Spoofing_Presentation.pptx
+++ b/CAN_Spoofing_Presentation.pptx
@@ -6,6 +6,14 @@
   </p:sldMasterIdLst>
   <p:sldIdLst>
     <p:sldId id="256" r:id="rId7"/>
+    <p:sldId id="257" r:id="rId8"/>
+    <p:sldId id="258" r:id="rId9"/>
+    <p:sldId id="259" r:id="rId10"/>
+    <p:sldId id="260" r:id="rId11"/>
+    <p:sldId id="261" r:id="rId12"/>
+    <p:sldId id="262" r:id="rId13"/>
+    <p:sldId id="263" r:id="rId14"/>
+    <p:sldId id="264" r:id="rId15"/>
   </p:sldIdLst>
   <p:sldSz cx="9144000" cy="6858000" type="screen4x3"/>
   <p:notesSz cx="6858000" cy="9144000"/>
@@ -3081,6 +3089,14 @@
 <file path=ppt/slides/slide1.xml><?xml version="1.0" encoding="utf-8"?>
 <p:sld xmlns:a="http://schemas.openxmlformats.org/drawingml/2006/main" xmlns:p="http://schemas.openxmlformats.org/presentationml/2006/main" xmlns:r="http://schemas.openxmlformats.org/officeDocument/2006/relationships">
   <p:cSld>
+    <p:bg>
+      <p:bgPr>
+        <a:solidFill>
+          <a:srgbClr val="0A1628"/>
+        </a:solidFill>
+        <a:effectLst/>
+      </p:bgPr>
+    </p:bg>
     <p:spTree>
       <p:nvGrpSpPr>
         <p:cNvPr id="1" name=""/>
@@ -3090,43 +3106,3596 @@
       <p:grpSpPr/>
       <p:sp>
         <p:nvSpPr>
-          <p:cNvPr id="2" name="Title 1"/>
-          <p:cNvSpPr>
-            <a:spLocks noGrp="1"/>
-          </p:cNvSpPr>
-          <p:nvPr>
-            <p:ph type="ctrTitle"/>
-          </p:nvPr>
-        </p:nvSpPr>
-        <p:spPr/>
-        <p:txBody>
-          <a:bodyPr/>
-          <a:lstStyle/>
-          <a:p>
-            <a:r>
-              <a:t>CAN Bus Spoofing Diagnostic Tool</a:t>
-            </a:r>
-          </a:p>
-        </p:txBody>
-      </p:sp>
-      <p:sp>
-        <p:nvSpPr>
-          <p:cNvPr id="3" name="Subtitle 2"/>
-          <p:cNvSpPr>
-            <a:spLocks noGrp="1"/>
-          </p:cNvSpPr>
-          <p:nvPr>
-            <p:ph type="subTitle" idx="1"/>
-          </p:nvPr>
-        </p:nvSpPr>
-        <p:spPr/>
-        <p:txBody>
-          <a:bodyPr/>
-          <a:lstStyle/>
-          <a:p>
-            <a:r>
-              <a:t>Automated Cyber Threat Detection for Vehicle Networks</a:t>
-            </a:r>
+          <p:cNvPr id="2" name="Rectangle 1"/>
+          <p:cNvSpPr/>
+          <p:nvPr/>
+        </p:nvSpPr>
+        <p:spPr>
+          <a:xfrm>
+            <a:off x="0" y="0"/>
+            <a:ext cx="9144000" cy="91440"/>
+          </a:xfrm>
+          <a:prstGeom prst="rect">
+            <a:avLst/>
+          </a:prstGeom>
+          <a:solidFill>
+            <a:srgbClr val="00D4FF"/>
+          </a:solidFill>
+          <a:ln>
+            <a:noFill/>
+          </a:ln>
+        </p:spPr>
+        <p:style>
+          <a:lnRef idx="1">
+            <a:schemeClr val="accent1"/>
+          </a:lnRef>
+          <a:fillRef idx="3">
+            <a:schemeClr val="accent1"/>
+          </a:fillRef>
+          <a:effectRef idx="2">
+            <a:schemeClr val="accent1"/>
+          </a:effectRef>
+          <a:fontRef idx="minor">
+            <a:schemeClr val="lt1"/>
+          </a:fontRef>
+        </p:style>
+        <p:txBody>
+          <a:bodyPr rtlCol="0" anchor="ctr"/>
+          <a:lstStyle/>
+          <a:p>
+            <a:pPr algn="ctr"/>
+          </a:p>
+        </p:txBody>
+      </p:sp>
+      <p:sp>
+        <p:nvSpPr>
+          <p:cNvPr id="3" name="Oval 2"/>
+          <p:cNvSpPr/>
+          <p:nvPr/>
+        </p:nvSpPr>
+        <p:spPr>
+          <a:xfrm>
+            <a:off x="3840480" y="1097280"/>
+            <a:ext cx="1463040" cy="1463040"/>
+          </a:xfrm>
+          <a:prstGeom prst="ellipse">
+            <a:avLst/>
+          </a:prstGeom>
+          <a:solidFill>
+            <a:srgbClr val="00D4FF"/>
+          </a:solidFill>
+          <a:ln>
+            <a:noFill/>
+          </a:ln>
+        </p:spPr>
+        <p:style>
+          <a:lnRef idx="1">
+            <a:schemeClr val="accent1"/>
+          </a:lnRef>
+          <a:fillRef idx="3">
+            <a:schemeClr val="accent1"/>
+          </a:fillRef>
+          <a:effectRef idx="2">
+            <a:schemeClr val="accent1"/>
+          </a:effectRef>
+          <a:fontRef idx="minor">
+            <a:schemeClr val="lt1"/>
+          </a:fontRef>
+        </p:style>
+        <p:txBody>
+          <a:bodyPr rtlCol="0" anchor="ctr"/>
+          <a:lstStyle/>
+          <a:p>
+            <a:pPr algn="ctr"/>
+          </a:p>
+        </p:txBody>
+      </p:sp>
+      <p:sp>
+        <p:nvSpPr>
+          <p:cNvPr id="4" name="TextBox 3"/>
+          <p:cNvSpPr txBox="1"/>
+          <p:nvPr/>
+        </p:nvSpPr>
+        <p:spPr>
+          <a:xfrm>
+            <a:off x="914400" y="2926080"/>
+            <a:ext cx="7315200" cy="1097280"/>
+          </a:xfrm>
+          <a:prstGeom prst="rect">
+            <a:avLst/>
+          </a:prstGeom>
+          <a:noFill/>
+        </p:spPr>
+        <p:txBody>
+          <a:bodyPr wrap="square">
+            <a:spAutoFit/>
+          </a:bodyPr>
+          <a:lstStyle/>
+          <a:p>
+            <a:pPr algn="ctr">
+              <a:defRPr sz="3200" b="1">
+                <a:solidFill>
+                  <a:srgbClr val="FFFFFF"/>
+                </a:solidFill>
+              </a:defRPr>
+            </a:pPr>
+            <a:r>
+              <a:t>CAN Bus Spoofing &amp; Injection</a:t>
+            </a:r>
+          </a:p>
+          <a:p>
+            <a:pPr algn="ctr">
+              <a:defRPr sz="3200" b="1">
+                <a:solidFill>
+                  <a:srgbClr val="00D4FF"/>
+                </a:solidFill>
+              </a:defRPr>
+            </a:pPr>
+            <a:r>
+              <a:t>Diagnostic Tool v2.0</a:t>
+            </a:r>
+          </a:p>
+        </p:txBody>
+      </p:sp>
+      <p:sp>
+        <p:nvSpPr>
+          <p:cNvPr id="5" name="TextBox 4"/>
+          <p:cNvSpPr txBox="1"/>
+          <p:nvPr/>
+        </p:nvSpPr>
+        <p:spPr>
+          <a:xfrm>
+            <a:off x="1371600" y="4389120"/>
+            <a:ext cx="6400800" cy="731520"/>
+          </a:xfrm>
+          <a:prstGeom prst="rect">
+            <a:avLst/>
+          </a:prstGeom>
+          <a:noFill/>
+        </p:spPr>
+        <p:txBody>
+          <a:bodyPr wrap="none">
+            <a:spAutoFit/>
+          </a:bodyPr>
+          <a:lstStyle/>
+          <a:p>
+            <a:pPr algn="ctr">
+              <a:defRPr sz="1600">
+                <a:solidFill>
+                  <a:srgbClr val="8899A6"/>
+                </a:solidFill>
+              </a:defRPr>
+            </a:pPr>
+            <a:r>
+              <a:t>Automated Cybersecurity Threat Detection for Vehicle Networks</a:t>
+            </a:r>
+          </a:p>
+        </p:txBody>
+      </p:sp>
+      <p:sp>
+        <p:nvSpPr>
+          <p:cNvPr id="6" name="TextBox 5"/>
+          <p:cNvSpPr txBox="1"/>
+          <p:nvPr/>
+        </p:nvSpPr>
+        <p:spPr>
+          <a:xfrm>
+            <a:off x="2286000" y="5303520"/>
+            <a:ext cx="4572000" cy="457200"/>
+          </a:xfrm>
+          <a:prstGeom prst="rect">
+            <a:avLst/>
+          </a:prstGeom>
+          <a:noFill/>
+        </p:spPr>
+        <p:txBody>
+          <a:bodyPr wrap="none">
+            <a:spAutoFit/>
+          </a:bodyPr>
+          <a:lstStyle/>
+          <a:p>
+            <a:pPr algn="ctr">
+              <a:defRPr sz="1100">
+                <a:solidFill>
+                  <a:srgbClr val="00D4FF"/>
+                </a:solidFill>
+              </a:defRPr>
+            </a:pPr>
+            <a:r>
+              <a:t>v2.0 Professional  |  100% Offline  |  Zero Installation</a:t>
+            </a:r>
+          </a:p>
+        </p:txBody>
+      </p:sp>
+      <p:sp>
+        <p:nvSpPr>
+          <p:cNvPr id="7" name="Rectangle 6"/>
+          <p:cNvSpPr/>
+          <p:nvPr/>
+        </p:nvSpPr>
+        <p:spPr>
+          <a:xfrm>
+            <a:off x="0" y="6720840"/>
+            <a:ext cx="9144000" cy="137160"/>
+          </a:xfrm>
+          <a:prstGeom prst="rect">
+            <a:avLst/>
+          </a:prstGeom>
+          <a:solidFill>
+            <a:srgbClr val="0056B3"/>
+          </a:solidFill>
+          <a:ln>
+            <a:noFill/>
+          </a:ln>
+        </p:spPr>
+        <p:style>
+          <a:lnRef idx="1">
+            <a:schemeClr val="accent1"/>
+          </a:lnRef>
+          <a:fillRef idx="3">
+            <a:schemeClr val="accent1"/>
+          </a:fillRef>
+          <a:effectRef idx="2">
+            <a:schemeClr val="accent1"/>
+          </a:effectRef>
+          <a:fontRef idx="minor">
+            <a:schemeClr val="lt1"/>
+          </a:fontRef>
+        </p:style>
+        <p:txBody>
+          <a:bodyPr rtlCol="0" anchor="ctr"/>
+          <a:lstStyle/>
+          <a:p>
+            <a:pPr algn="ctr"/>
+          </a:p>
+        </p:txBody>
+      </p:sp>
+    </p:spTree>
+  </p:cSld>
+  <p:clrMapOvr>
+    <a:masterClrMapping/>
+  </p:clrMapOvr>
+</p:sld>
+</file>
+
+<file path=ppt/slides/slide2.xml><?xml version="1.0" encoding="utf-8"?>
+<p:sld xmlns:a="http://schemas.openxmlformats.org/drawingml/2006/main" xmlns:p="http://schemas.openxmlformats.org/presentationml/2006/main" xmlns:r="http://schemas.openxmlformats.org/officeDocument/2006/relationships">
+  <p:cSld>
+    <p:bg>
+      <p:bgPr>
+        <a:solidFill>
+          <a:srgbClr val="0F1419"/>
+        </a:solidFill>
+        <a:effectLst/>
+      </p:bgPr>
+    </p:bg>
+    <p:spTree>
+      <p:nvGrpSpPr>
+        <p:cNvPr id="1" name=""/>
+        <p:cNvGrpSpPr/>
+        <p:nvPr/>
+      </p:nvGrpSpPr>
+      <p:grpSpPr/>
+      <p:sp>
+        <p:nvSpPr>
+          <p:cNvPr id="2" name="Rectangle 1"/>
+          <p:cNvSpPr/>
+          <p:nvPr/>
+        </p:nvSpPr>
+        <p:spPr>
+          <a:xfrm>
+            <a:off x="0" y="0"/>
+            <a:ext cx="9144000" cy="73152"/>
+          </a:xfrm>
+          <a:prstGeom prst="rect">
+            <a:avLst/>
+          </a:prstGeom>
+          <a:solidFill>
+            <a:srgbClr val="00D4FF"/>
+          </a:solidFill>
+          <a:ln>
+            <a:noFill/>
+          </a:ln>
+        </p:spPr>
+        <p:style>
+          <a:lnRef idx="1">
+            <a:schemeClr val="accent1"/>
+          </a:lnRef>
+          <a:fillRef idx="3">
+            <a:schemeClr val="accent1"/>
+          </a:fillRef>
+          <a:effectRef idx="2">
+            <a:schemeClr val="accent1"/>
+          </a:effectRef>
+          <a:fontRef idx="minor">
+            <a:schemeClr val="lt1"/>
+          </a:fontRef>
+        </p:style>
+        <p:txBody>
+          <a:bodyPr rtlCol="0" anchor="ctr"/>
+          <a:lstStyle/>
+          <a:p>
+            <a:pPr algn="ctr"/>
+          </a:p>
+        </p:txBody>
+      </p:sp>
+      <p:sp>
+        <p:nvSpPr>
+          <p:cNvPr id="3" name="TextBox 2"/>
+          <p:cNvSpPr txBox="1"/>
+          <p:nvPr/>
+        </p:nvSpPr>
+        <p:spPr>
+          <a:xfrm>
+            <a:off x="731520" y="365760"/>
+            <a:ext cx="7772400" cy="731520"/>
+          </a:xfrm>
+          <a:prstGeom prst="rect">
+            <a:avLst/>
+          </a:prstGeom>
+          <a:noFill/>
+        </p:spPr>
+        <p:txBody>
+          <a:bodyPr wrap="square">
+            <a:spAutoFit/>
+          </a:bodyPr>
+          <a:lstStyle/>
+          <a:p>
+            <a:pPr>
+              <a:defRPr sz="2800" b="1">
+                <a:solidFill>
+                  <a:srgbClr val="00D4FF"/>
+                </a:solidFill>
+              </a:defRPr>
+            </a:pPr>
+            <a:r>
+              <a:t>The Problem: CAN Bus Vulnerabilities</a:t>
+            </a:r>
+          </a:p>
+        </p:txBody>
+      </p:sp>
+      <p:sp>
+        <p:nvSpPr>
+          <p:cNvPr id="4" name="TextBox 3"/>
+          <p:cNvSpPr txBox="1"/>
+          <p:nvPr/>
+        </p:nvSpPr>
+        <p:spPr>
+          <a:xfrm>
+            <a:off x="731520" y="1097280"/>
+            <a:ext cx="7772400" cy="457200"/>
+          </a:xfrm>
+          <a:prstGeom prst="rect">
+            <a:avLst/>
+          </a:prstGeom>
+          <a:noFill/>
+        </p:spPr>
+        <p:txBody>
+          <a:bodyPr wrap="none">
+            <a:spAutoFit/>
+          </a:bodyPr>
+          <a:lstStyle/>
+          <a:p>
+            <a:pPr>
+              <a:defRPr sz="1400">
+                <a:solidFill>
+                  <a:srgbClr val="8899A6"/>
+                </a:solidFill>
+              </a:defRPr>
+            </a:pPr>
+            <a:r>
+              <a:t>Why automotive networks are critically exposed</a:t>
+            </a:r>
+          </a:p>
+        </p:txBody>
+      </p:sp>
+      <p:sp>
+        <p:nvSpPr>
+          <p:cNvPr id="5" name="TextBox 4"/>
+          <p:cNvSpPr txBox="1"/>
+          <p:nvPr/>
+        </p:nvSpPr>
+        <p:spPr>
+          <a:xfrm>
+            <a:off x="731520" y="1737360"/>
+            <a:ext cx="7680960" cy="4572000"/>
+          </a:xfrm>
+          <a:prstGeom prst="rect">
+            <a:avLst/>
+          </a:prstGeom>
+          <a:noFill/>
+        </p:spPr>
+        <p:txBody>
+          <a:bodyPr wrap="square">
+            <a:spAutoFit/>
+          </a:bodyPr>
+          <a:lstStyle/>
+          <a:p>
+            <a:pPr>
+              <a:spcBef>
+                <a:spcPts val="1400"/>
+              </a:spcBef>
+              <a:defRPr sz="1600" b="1">
+                <a:solidFill>
+                  <a:srgbClr val="FFFFFF"/>
+                </a:solidFill>
+              </a:defRPr>
+            </a:pPr>
+            <a:r>
+              <a:t>The CAN Protocol Has No Built-in Security</a:t>
+            </a:r>
+          </a:p>
+          <a:p>
+            <a:pPr>
+              <a:spcBef>
+                <a:spcPts val="600"/>
+              </a:spcBef>
+              <a:defRPr sz="1300">
+                <a:solidFill>
+                  <a:srgbClr val="CCDDEE"/>
+                </a:solidFill>
+              </a:defRPr>
+            </a:pPr>
+            <a:r>
+              <a:t>Designed in 1986 — no authentication, encryption, or access control</a:t>
+            </a:r>
+          </a:p>
+          <a:p>
+            <a:pPr>
+              <a:spcBef>
+                <a:spcPts val="600"/>
+              </a:spcBef>
+              <a:defRPr sz="1300">
+                <a:solidFill>
+                  <a:srgbClr val="CCDDEE"/>
+                </a:solidFill>
+              </a:defRPr>
+            </a:pPr>
+            <a:r>
+              <a:t>Any node on the bus can send ANY message to ANY ECU</a:t>
+            </a:r>
+          </a:p>
+          <a:p>
+            <a:pPr>
+              <a:spcBef>
+                <a:spcPts val="600"/>
+              </a:spcBef>
+              <a:defRPr sz="1300">
+                <a:solidFill>
+                  <a:srgbClr val="CCDDEE"/>
+                </a:solidFill>
+              </a:defRPr>
+            </a:pPr>
+            <a:r>
+              <a:t>No sender verification — enables trivial message spoofing</a:t>
+            </a:r>
+          </a:p>
+          <a:p>
+            <a:pPr>
+              <a:spcBef>
+                <a:spcPts val="400"/>
+              </a:spcBef>
+            </a:pPr>
+          </a:p>
+          <a:p>
+            <a:pPr>
+              <a:spcBef>
+                <a:spcPts val="1400"/>
+              </a:spcBef>
+              <a:defRPr sz="1600" b="1">
+                <a:solidFill>
+                  <a:srgbClr val="FFFFFF"/>
+                </a:solidFill>
+              </a:defRPr>
+            </a:pPr>
+            <a:r>
+              <a:t>Real-World Attack Vectors</a:t>
+            </a:r>
+          </a:p>
+          <a:p>
+            <a:pPr>
+              <a:spcBef>
+                <a:spcPts val="600"/>
+              </a:spcBef>
+              <a:defRPr sz="1300">
+                <a:solidFill>
+                  <a:srgbClr val="CCDDEE"/>
+                </a:solidFill>
+              </a:defRPr>
+            </a:pPr>
+            <a:r>
+              <a:t>Message Injection — Override legitimate ECU signals at high frequency</a:t>
+            </a:r>
+          </a:p>
+          <a:p>
+            <a:pPr>
+              <a:spcBef>
+                <a:spcPts val="600"/>
+              </a:spcBef>
+              <a:defRPr sz="1300">
+                <a:solidFill>
+                  <a:srgbClr val="CCDDEE"/>
+                </a:solidFill>
+              </a:defRPr>
+            </a:pPr>
+            <a:r>
+              <a:t>Replay Attacks — Re-transmit captured legitimate messages</a:t>
+            </a:r>
+          </a:p>
+          <a:p>
+            <a:pPr>
+              <a:spcBef>
+                <a:spcPts val="600"/>
+              </a:spcBef>
+              <a:defRPr sz="1300">
+                <a:solidFill>
+                  <a:srgbClr val="CCDDEE"/>
+                </a:solidFill>
+              </a:defRPr>
+            </a:pPr>
+            <a:r>
+              <a:t>Denial of Service — Flood bus with highest-priority messages</a:t>
+            </a:r>
+          </a:p>
+          <a:p>
+            <a:pPr>
+              <a:spcBef>
+                <a:spcPts val="600"/>
+              </a:spcBef>
+              <a:defRPr sz="1300">
+                <a:solidFill>
+                  <a:srgbClr val="CCDDEE"/>
+                </a:solidFill>
+              </a:defRPr>
+            </a:pPr>
+            <a:r>
+              <a:t>Fuzzing — Discover exploitable behaviors via random messages</a:t>
+            </a:r>
+          </a:p>
+          <a:p>
+            <a:pPr>
+              <a:spcBef>
+                <a:spcPts val="400"/>
+              </a:spcBef>
+            </a:pPr>
+          </a:p>
+          <a:p>
+            <a:pPr>
+              <a:spcBef>
+                <a:spcPts val="1400"/>
+              </a:spcBef>
+              <a:defRPr sz="1600" b="1">
+                <a:solidFill>
+                  <a:srgbClr val="FFFFFF"/>
+                </a:solidFill>
+              </a:defRPr>
+            </a:pPr>
+            <a:r>
+              <a:t>Business &amp; Safety Impact</a:t>
+            </a:r>
+          </a:p>
+          <a:p>
+            <a:pPr>
+              <a:spcBef>
+                <a:spcPts val="600"/>
+              </a:spcBef>
+              <a:defRPr sz="1300">
+                <a:solidFill>
+                  <a:srgbClr val="CCDDEE"/>
+                </a:solidFill>
+              </a:defRPr>
+            </a:pPr>
+            <a:r>
+              <a:t>Safety recalls (Jeep Cherokee 2015 remote exploit: 1.4M vehicles)</a:t>
+            </a:r>
+          </a:p>
+          <a:p>
+            <a:pPr>
+              <a:spcBef>
+                <a:spcPts val="600"/>
+              </a:spcBef>
+              <a:defRPr sz="1300">
+                <a:solidFill>
+                  <a:srgbClr val="CCDDEE"/>
+                </a:solidFill>
+              </a:defRPr>
+            </a:pPr>
+            <a:r>
+              <a:t>UNECE WP.29 &amp; ISO/SAE 21434 mandate cybersecurity processes</a:t>
+            </a:r>
+          </a:p>
+          <a:p>
+            <a:pPr>
+              <a:spcBef>
+                <a:spcPts val="600"/>
+              </a:spcBef>
+              <a:defRPr sz="1300">
+                <a:solidFill>
+                  <a:srgbClr val="CCDDEE"/>
+                </a:solidFill>
+              </a:defRPr>
+            </a:pPr>
+            <a:r>
+              <a:t>Manual analysis: 4-8 hours per investigation — unsustainable at scale</a:t>
+            </a:r>
+          </a:p>
+        </p:txBody>
+      </p:sp>
+      <p:sp>
+        <p:nvSpPr>
+          <p:cNvPr id="6" name="Rectangle 5"/>
+          <p:cNvSpPr/>
+          <p:nvPr/>
+        </p:nvSpPr>
+        <p:spPr>
+          <a:xfrm>
+            <a:off x="0" y="6720840"/>
+            <a:ext cx="9144000" cy="137160"/>
+          </a:xfrm>
+          <a:prstGeom prst="rect">
+            <a:avLst/>
+          </a:prstGeom>
+          <a:solidFill>
+            <a:srgbClr val="0056B3"/>
+          </a:solidFill>
+          <a:ln>
+            <a:noFill/>
+          </a:ln>
+        </p:spPr>
+        <p:style>
+          <a:lnRef idx="1">
+            <a:schemeClr val="accent1"/>
+          </a:lnRef>
+          <a:fillRef idx="3">
+            <a:schemeClr val="accent1"/>
+          </a:fillRef>
+          <a:effectRef idx="2">
+            <a:schemeClr val="accent1"/>
+          </a:effectRef>
+          <a:fontRef idx="minor">
+            <a:schemeClr val="lt1"/>
+          </a:fontRef>
+        </p:style>
+        <p:txBody>
+          <a:bodyPr rtlCol="0" anchor="ctr"/>
+          <a:lstStyle/>
+          <a:p>
+            <a:pPr algn="ctr"/>
+          </a:p>
+        </p:txBody>
+      </p:sp>
+    </p:spTree>
+  </p:cSld>
+  <p:clrMapOvr>
+    <a:masterClrMapping/>
+  </p:clrMapOvr>
+</p:sld>
+</file>
+
+<file path=ppt/slides/slide3.xml><?xml version="1.0" encoding="utf-8"?>
+<p:sld xmlns:a="http://schemas.openxmlformats.org/drawingml/2006/main" xmlns:p="http://schemas.openxmlformats.org/presentationml/2006/main" xmlns:r="http://schemas.openxmlformats.org/officeDocument/2006/relationships">
+  <p:cSld>
+    <p:bg>
+      <p:bgPr>
+        <a:solidFill>
+          <a:srgbClr val="0F1419"/>
+        </a:solidFill>
+        <a:effectLst/>
+      </p:bgPr>
+    </p:bg>
+    <p:spTree>
+      <p:nvGrpSpPr>
+        <p:cNvPr id="1" name=""/>
+        <p:cNvGrpSpPr/>
+        <p:nvPr/>
+      </p:nvGrpSpPr>
+      <p:grpSpPr/>
+      <p:sp>
+        <p:nvSpPr>
+          <p:cNvPr id="2" name="Rectangle 1"/>
+          <p:cNvSpPr/>
+          <p:nvPr/>
+        </p:nvSpPr>
+        <p:spPr>
+          <a:xfrm>
+            <a:off x="0" y="0"/>
+            <a:ext cx="9144000" cy="73152"/>
+          </a:xfrm>
+          <a:prstGeom prst="rect">
+            <a:avLst/>
+          </a:prstGeom>
+          <a:solidFill>
+            <a:srgbClr val="00D4FF"/>
+          </a:solidFill>
+          <a:ln>
+            <a:noFill/>
+          </a:ln>
+        </p:spPr>
+        <p:style>
+          <a:lnRef idx="1">
+            <a:schemeClr val="accent1"/>
+          </a:lnRef>
+          <a:fillRef idx="3">
+            <a:schemeClr val="accent1"/>
+          </a:fillRef>
+          <a:effectRef idx="2">
+            <a:schemeClr val="accent1"/>
+          </a:effectRef>
+          <a:fontRef idx="minor">
+            <a:schemeClr val="lt1"/>
+          </a:fontRef>
+        </p:style>
+        <p:txBody>
+          <a:bodyPr rtlCol="0" anchor="ctr"/>
+          <a:lstStyle/>
+          <a:p>
+            <a:pPr algn="ctr"/>
+          </a:p>
+        </p:txBody>
+      </p:sp>
+      <p:sp>
+        <p:nvSpPr>
+          <p:cNvPr id="3" name="TextBox 2"/>
+          <p:cNvSpPr txBox="1"/>
+          <p:nvPr/>
+        </p:nvSpPr>
+        <p:spPr>
+          <a:xfrm>
+            <a:off x="731520" y="365760"/>
+            <a:ext cx="7772400" cy="731520"/>
+          </a:xfrm>
+          <a:prstGeom prst="rect">
+            <a:avLst/>
+          </a:prstGeom>
+          <a:noFill/>
+        </p:spPr>
+        <p:txBody>
+          <a:bodyPr wrap="square">
+            <a:spAutoFit/>
+          </a:bodyPr>
+          <a:lstStyle/>
+          <a:p>
+            <a:pPr>
+              <a:defRPr sz="2800" b="1">
+                <a:solidFill>
+                  <a:srgbClr val="00D4FF"/>
+                </a:solidFill>
+              </a:defRPr>
+            </a:pPr>
+            <a:r>
+              <a:t>The Solution: Automated Detection</a:t>
+            </a:r>
+          </a:p>
+        </p:txBody>
+      </p:sp>
+      <p:sp>
+        <p:nvSpPr>
+          <p:cNvPr id="4" name="TextBox 3"/>
+          <p:cNvSpPr txBox="1"/>
+          <p:nvPr/>
+        </p:nvSpPr>
+        <p:spPr>
+          <a:xfrm>
+            <a:off x="731520" y="1097280"/>
+            <a:ext cx="7772400" cy="457200"/>
+          </a:xfrm>
+          <a:prstGeom prst="rect">
+            <a:avLst/>
+          </a:prstGeom>
+          <a:noFill/>
+        </p:spPr>
+        <p:txBody>
+          <a:bodyPr wrap="none">
+            <a:spAutoFit/>
+          </a:bodyPr>
+          <a:lstStyle/>
+          <a:p>
+            <a:pPr>
+              <a:defRPr sz="1400">
+                <a:solidFill>
+                  <a:srgbClr val="8899A6"/>
+                </a:solidFill>
+              </a:defRPr>
+            </a:pPr>
+            <a:r>
+              <a:t>Browser-based, offline, zero-installation diagnostic tool</a:t>
+            </a:r>
+          </a:p>
+        </p:txBody>
+      </p:sp>
+      <p:sp>
+        <p:nvSpPr>
+          <p:cNvPr id="5" name="TextBox 4"/>
+          <p:cNvSpPr txBox="1"/>
+          <p:nvPr/>
+        </p:nvSpPr>
+        <p:spPr>
+          <a:xfrm>
+            <a:off x="731520" y="1737360"/>
+            <a:ext cx="7680960" cy="4572000"/>
+          </a:xfrm>
+          <a:prstGeom prst="rect">
+            <a:avLst/>
+          </a:prstGeom>
+          <a:noFill/>
+        </p:spPr>
+        <p:txBody>
+          <a:bodyPr wrap="square">
+            <a:spAutoFit/>
+          </a:bodyPr>
+          <a:lstStyle/>
+          <a:p>
+            <a:pPr>
+              <a:spcBef>
+                <a:spcPts val="1400"/>
+              </a:spcBef>
+              <a:defRPr sz="1600" b="1">
+                <a:solidFill>
+                  <a:srgbClr val="FFFFFF"/>
+                </a:solidFill>
+              </a:defRPr>
+            </a:pPr>
+            <a:r>
+              <a:t>Multi-Dimensional Detection Engine</a:t>
+            </a:r>
+          </a:p>
+          <a:p>
+            <a:pPr>
+              <a:spcBef>
+                <a:spcPts val="600"/>
+              </a:spcBef>
+              <a:defRPr sz="1300">
+                <a:solidFill>
+                  <a:srgbClr val="CCDDEE"/>
+                </a:solidFill>
+              </a:defRPr>
+            </a:pPr>
+            <a:r>
+              <a:t>Timing Analysis — Messages faster than expected = injection</a:t>
+            </a:r>
+          </a:p>
+          <a:p>
+            <a:pPr>
+              <a:spcBef>
+                <a:spcPts val="600"/>
+              </a:spcBef>
+              <a:defRPr sz="1300">
+                <a:solidFill>
+                  <a:srgbClr val="CCDDEE"/>
+                </a:solidFill>
+              </a:defRPr>
+            </a:pPr>
+            <a:r>
+              <a:t>Statistical Profiling — Mean, min, max, std dev per CAN ID</a:t>
+            </a:r>
+          </a:p>
+          <a:p>
+            <a:pPr>
+              <a:spcBef>
+                <a:spcPts val="600"/>
+              </a:spcBef>
+              <a:defRPr sz="1300">
+                <a:solidFill>
+                  <a:srgbClr val="CCDDEE"/>
+                </a:solidFill>
+              </a:defRPr>
+            </a:pPr>
+            <a:r>
+              <a:t>Burst Detection — Cluster identification of rapid injection windows</a:t>
+            </a:r>
+          </a:p>
+          <a:p>
+            <a:pPr>
+              <a:spcBef>
+                <a:spcPts val="600"/>
+              </a:spcBef>
+              <a:defRPr sz="1300">
+                <a:solidFill>
+                  <a:srgbClr val="CCDDEE"/>
+                </a:solidFill>
+              </a:defRPr>
+            </a:pPr>
+            <a:r>
+              <a:t>Per-ID Classification — NORMAL / SUSPICIOUS / SPOOFED verdicts</a:t>
+            </a:r>
+          </a:p>
+          <a:p>
+            <a:pPr>
+              <a:spcBef>
+                <a:spcPts val="600"/>
+              </a:spcBef>
+              <a:defRPr sz="1300">
+                <a:solidFill>
+                  <a:srgbClr val="CCDDEE"/>
+                </a:solidFill>
+              </a:defRPr>
+            </a:pPr>
+            <a:r>
+              <a:t>Network Health Score — Single-number bus integrity metric</a:t>
+            </a:r>
+          </a:p>
+          <a:p>
+            <a:pPr>
+              <a:spcBef>
+                <a:spcPts val="400"/>
+              </a:spcBef>
+            </a:pPr>
+          </a:p>
+          <a:p>
+            <a:pPr>
+              <a:spcBef>
+                <a:spcPts val="1400"/>
+              </a:spcBef>
+              <a:defRPr sz="1600" b="1">
+                <a:solidFill>
+                  <a:srgbClr val="FFFFFF"/>
+                </a:solidFill>
+              </a:defRPr>
+            </a:pPr>
+            <a:r>
+              <a:t>Key Advantages</a:t>
+            </a:r>
+          </a:p>
+          <a:p>
+            <a:pPr>
+              <a:spcBef>
+                <a:spcPts val="600"/>
+              </a:spcBef>
+              <a:defRPr sz="1300">
+                <a:solidFill>
+                  <a:srgbClr val="CCDDEE"/>
+                </a:solidFill>
+              </a:defRPr>
+            </a:pPr>
+            <a:r>
+              <a:t>Zero Installation — opens directly in any browser</a:t>
+            </a:r>
+          </a:p>
+          <a:p>
+            <a:pPr>
+              <a:spcBef>
+                <a:spcPts val="600"/>
+              </a:spcBef>
+              <a:defRPr sz="1300">
+                <a:solidFill>
+                  <a:srgbClr val="CCDDEE"/>
+                </a:solidFill>
+              </a:defRPr>
+            </a:pPr>
+            <a:r>
+              <a:t>100% Offline — data never leaves the machine</a:t>
+            </a:r>
+          </a:p>
+          <a:p>
+            <a:pPr>
+              <a:spcBef>
+                <a:spcPts val="600"/>
+              </a:spcBef>
+              <a:defRPr sz="1300">
+                <a:solidFill>
+                  <a:srgbClr val="CCDDEE"/>
+                </a:solidFill>
+              </a:defRPr>
+            </a:pPr>
+            <a:r>
+              <a:t>Sub-second — 5000+ messages in milliseconds</a:t>
+            </a:r>
+          </a:p>
+          <a:p>
+            <a:pPr>
+              <a:spcBef>
+                <a:spcPts val="600"/>
+              </a:spcBef>
+              <a:defRPr sz="1300">
+                <a:solidFill>
+                  <a:srgbClr val="CCDDEE"/>
+                </a:solidFill>
+              </a:defRPr>
+            </a:pPr>
+            <a:r>
+              <a:t>Configurable — adapts to any vehicle architecture</a:t>
+            </a:r>
+          </a:p>
+          <a:p>
+            <a:pPr>
+              <a:spcBef>
+                <a:spcPts val="600"/>
+              </a:spcBef>
+              <a:defRPr sz="1300">
+                <a:solidFill>
+                  <a:srgbClr val="CCDDEE"/>
+                </a:solidFill>
+              </a:defRPr>
+            </a:pPr>
+            <a:r>
+              <a:t>Professional Export — CSV, JSON, TXT, Print/PDF</a:t>
+            </a:r>
+          </a:p>
+          <a:p>
+            <a:pPr>
+              <a:spcBef>
+                <a:spcPts val="400"/>
+              </a:spcBef>
+            </a:pPr>
+          </a:p>
+          <a:p>
+            <a:pPr>
+              <a:spcBef>
+                <a:spcPts val="1400"/>
+              </a:spcBef>
+              <a:defRPr sz="1600" b="1">
+                <a:solidFill>
+                  <a:srgbClr val="FFFFFF"/>
+                </a:solidFill>
+              </a:defRPr>
+            </a:pPr>
+            <a:r>
+              <a:t>ROI: 4-8 hours → 5 seconds per investigation</a:t>
+            </a:r>
+          </a:p>
+        </p:txBody>
+      </p:sp>
+      <p:sp>
+        <p:nvSpPr>
+          <p:cNvPr id="6" name="Rectangle 5"/>
+          <p:cNvSpPr/>
+          <p:nvPr/>
+        </p:nvSpPr>
+        <p:spPr>
+          <a:xfrm>
+            <a:off x="0" y="6720840"/>
+            <a:ext cx="9144000" cy="137160"/>
+          </a:xfrm>
+          <a:prstGeom prst="rect">
+            <a:avLst/>
+          </a:prstGeom>
+          <a:solidFill>
+            <a:srgbClr val="0056B3"/>
+          </a:solidFill>
+          <a:ln>
+            <a:noFill/>
+          </a:ln>
+        </p:spPr>
+        <p:style>
+          <a:lnRef idx="1">
+            <a:schemeClr val="accent1"/>
+          </a:lnRef>
+          <a:fillRef idx="3">
+            <a:schemeClr val="accent1"/>
+          </a:fillRef>
+          <a:effectRef idx="2">
+            <a:schemeClr val="accent1"/>
+          </a:effectRef>
+          <a:fontRef idx="minor">
+            <a:schemeClr val="lt1"/>
+          </a:fontRef>
+        </p:style>
+        <p:txBody>
+          <a:bodyPr rtlCol="0" anchor="ctr"/>
+          <a:lstStyle/>
+          <a:p>
+            <a:pPr algn="ctr"/>
+          </a:p>
+        </p:txBody>
+      </p:sp>
+    </p:spTree>
+  </p:cSld>
+  <p:clrMapOvr>
+    <a:masterClrMapping/>
+  </p:clrMapOvr>
+</p:sld>
+</file>
+
+<file path=ppt/slides/slide4.xml><?xml version="1.0" encoding="utf-8"?>
+<p:sld xmlns:a="http://schemas.openxmlformats.org/drawingml/2006/main" xmlns:p="http://schemas.openxmlformats.org/presentationml/2006/main" xmlns:r="http://schemas.openxmlformats.org/officeDocument/2006/relationships">
+  <p:cSld>
+    <p:bg>
+      <p:bgPr>
+        <a:solidFill>
+          <a:srgbClr val="0F1419"/>
+        </a:solidFill>
+        <a:effectLst/>
+      </p:bgPr>
+    </p:bg>
+    <p:spTree>
+      <p:nvGrpSpPr>
+        <p:cNvPr id="1" name=""/>
+        <p:cNvGrpSpPr/>
+        <p:nvPr/>
+      </p:nvGrpSpPr>
+      <p:grpSpPr/>
+      <p:sp>
+        <p:nvSpPr>
+          <p:cNvPr id="2" name="Rectangle 1"/>
+          <p:cNvSpPr/>
+          <p:nvPr/>
+        </p:nvSpPr>
+        <p:spPr>
+          <a:xfrm>
+            <a:off x="0" y="0"/>
+            <a:ext cx="9144000" cy="73152"/>
+          </a:xfrm>
+          <a:prstGeom prst="rect">
+            <a:avLst/>
+          </a:prstGeom>
+          <a:solidFill>
+            <a:srgbClr val="00D4FF"/>
+          </a:solidFill>
+          <a:ln>
+            <a:noFill/>
+          </a:ln>
+        </p:spPr>
+        <p:style>
+          <a:lnRef idx="1">
+            <a:schemeClr val="accent1"/>
+          </a:lnRef>
+          <a:fillRef idx="3">
+            <a:schemeClr val="accent1"/>
+          </a:fillRef>
+          <a:effectRef idx="2">
+            <a:schemeClr val="accent1"/>
+          </a:effectRef>
+          <a:fontRef idx="minor">
+            <a:schemeClr val="lt1"/>
+          </a:fontRef>
+        </p:style>
+        <p:txBody>
+          <a:bodyPr rtlCol="0" anchor="ctr"/>
+          <a:lstStyle/>
+          <a:p>
+            <a:pPr algn="ctr"/>
+          </a:p>
+        </p:txBody>
+      </p:sp>
+      <p:sp>
+        <p:nvSpPr>
+          <p:cNvPr id="3" name="TextBox 2"/>
+          <p:cNvSpPr txBox="1"/>
+          <p:nvPr/>
+        </p:nvSpPr>
+        <p:spPr>
+          <a:xfrm>
+            <a:off x="731520" y="365760"/>
+            <a:ext cx="7772400" cy="731520"/>
+          </a:xfrm>
+          <a:prstGeom prst="rect">
+            <a:avLst/>
+          </a:prstGeom>
+          <a:noFill/>
+        </p:spPr>
+        <p:txBody>
+          <a:bodyPr wrap="square">
+            <a:spAutoFit/>
+          </a:bodyPr>
+          <a:lstStyle/>
+          <a:p>
+            <a:pPr>
+              <a:defRPr sz="2800" b="1">
+                <a:solidFill>
+                  <a:srgbClr val="00D4FF"/>
+                </a:solidFill>
+              </a:defRPr>
+            </a:pPr>
+            <a:r>
+              <a:t>How It Works: 4 Simple Steps</a:t>
+            </a:r>
+          </a:p>
+        </p:txBody>
+      </p:sp>
+      <p:sp>
+        <p:nvSpPr>
+          <p:cNvPr id="4" name="TextBox 3"/>
+          <p:cNvSpPr txBox="1"/>
+          <p:nvPr/>
+        </p:nvSpPr>
+        <p:spPr>
+          <a:xfrm>
+            <a:off x="731520" y="1097280"/>
+            <a:ext cx="7772400" cy="457200"/>
+          </a:xfrm>
+          <a:prstGeom prst="rect">
+            <a:avLst/>
+          </a:prstGeom>
+          <a:noFill/>
+        </p:spPr>
+        <p:txBody>
+          <a:bodyPr wrap="none">
+            <a:spAutoFit/>
+          </a:bodyPr>
+          <a:lstStyle/>
+          <a:p>
+            <a:pPr>
+              <a:defRPr sz="1400">
+                <a:solidFill>
+                  <a:srgbClr val="8899A6"/>
+                </a:solidFill>
+              </a:defRPr>
+            </a:pPr>
+            <a:r>
+              <a:t>From raw log to actionable diagnostic in seconds</a:t>
+            </a:r>
+          </a:p>
+        </p:txBody>
+      </p:sp>
+      <p:sp>
+        <p:nvSpPr>
+          <p:cNvPr id="5" name="TextBox 4"/>
+          <p:cNvSpPr txBox="1"/>
+          <p:nvPr/>
+        </p:nvSpPr>
+        <p:spPr>
+          <a:xfrm>
+            <a:off x="731520" y="1737360"/>
+            <a:ext cx="7680960" cy="4572000"/>
+          </a:xfrm>
+          <a:prstGeom prst="rect">
+            <a:avLst/>
+          </a:prstGeom>
+          <a:noFill/>
+        </p:spPr>
+        <p:txBody>
+          <a:bodyPr wrap="square">
+            <a:spAutoFit/>
+          </a:bodyPr>
+          <a:lstStyle/>
+          <a:p>
+            <a:pPr>
+              <a:spcBef>
+                <a:spcPts val="1400"/>
+              </a:spcBef>
+              <a:defRPr sz="1600" b="1">
+                <a:solidFill>
+                  <a:srgbClr val="FFFFFF"/>
+                </a:solidFill>
+              </a:defRPr>
+            </a:pPr>
+            <a:r>
+              <a:t>Step 1: Load CAN Log Data</a:t>
+            </a:r>
+          </a:p>
+          <a:p>
+            <a:pPr>
+              <a:spcBef>
+                <a:spcPts val="600"/>
+              </a:spcBef>
+              <a:defRPr sz="1300">
+                <a:solidFill>
+                  <a:srgbClr val="CCDDEE"/>
+                </a:solidFill>
+              </a:defRPr>
+            </a:pPr>
+            <a:r>
+              <a:t>Drag &amp; drop .asc / .csv / .txt / .log files</a:t>
+            </a:r>
+          </a:p>
+          <a:p>
+            <a:pPr>
+              <a:spcBef>
+                <a:spcPts val="600"/>
+              </a:spcBef>
+              <a:defRPr sz="1300">
+                <a:solidFill>
+                  <a:srgbClr val="CCDDEE"/>
+                </a:solidFill>
+              </a:defRPr>
+            </a:pPr>
+            <a:r>
+              <a:t>Or paste data directly, or use built-in demo scenarios</a:t>
+            </a:r>
+          </a:p>
+          <a:p>
+            <a:pPr>
+              <a:spcBef>
+                <a:spcPts val="400"/>
+              </a:spcBef>
+            </a:pPr>
+          </a:p>
+          <a:p>
+            <a:pPr>
+              <a:spcBef>
+                <a:spcPts val="1400"/>
+              </a:spcBef>
+              <a:defRPr sz="1600" b="1">
+                <a:solidFill>
+                  <a:srgbClr val="FFFFFF"/>
+                </a:solidFill>
+              </a:defRPr>
+            </a:pPr>
+            <a:r>
+              <a:t>Step 2: Configure Detection Parameters</a:t>
+            </a:r>
+          </a:p>
+          <a:p>
+            <a:pPr>
+              <a:spcBef>
+                <a:spcPts val="600"/>
+              </a:spcBef>
+              <a:defRPr sz="1300">
+                <a:solidFill>
+                  <a:srgbClr val="CCDDEE"/>
+                </a:solidFill>
+              </a:defRPr>
+            </a:pPr>
+            <a:r>
+              <a:t>Spoofing threshold (default 5ms) — below this = SPOOFED</a:t>
+            </a:r>
+          </a:p>
+          <a:p>
+            <a:pPr>
+              <a:spcBef>
+                <a:spcPts val="600"/>
+              </a:spcBef>
+              <a:defRPr sz="1300">
+                <a:solidFill>
+                  <a:srgbClr val="CCDDEE"/>
+                </a:solidFill>
+              </a:defRPr>
+            </a:pPr>
+            <a:r>
+              <a:t>Suspicious threshold (default 8ms) — between thresholds = SUSPICIOUS</a:t>
+            </a:r>
+          </a:p>
+          <a:p>
+            <a:pPr>
+              <a:spcBef>
+                <a:spcPts val="600"/>
+              </a:spcBef>
+              <a:defRPr sz="1300">
+                <a:solidFill>
+                  <a:srgbClr val="CCDDEE"/>
+                </a:solidFill>
+              </a:defRPr>
+            </a:pPr>
+            <a:r>
+              <a:t>Analysis mode: Timing / Frequency / Payload / Comprehensive</a:t>
+            </a:r>
+          </a:p>
+          <a:p>
+            <a:pPr>
+              <a:spcBef>
+                <a:spcPts val="400"/>
+              </a:spcBef>
+            </a:pPr>
+          </a:p>
+          <a:p>
+            <a:pPr>
+              <a:spcBef>
+                <a:spcPts val="1400"/>
+              </a:spcBef>
+              <a:defRPr sz="1600" b="1">
+                <a:solidFill>
+                  <a:srgbClr val="FFFFFF"/>
+                </a:solidFill>
+              </a:defRPr>
+            </a:pPr>
+            <a:r>
+              <a:t>Step 3: Analyze &amp; Interpret Results</a:t>
+            </a:r>
+          </a:p>
+          <a:p>
+            <a:pPr>
+              <a:spcBef>
+                <a:spcPts val="600"/>
+              </a:spcBef>
+              <a:defRPr sz="1300">
+                <a:solidFill>
+                  <a:srgbClr val="CCDDEE"/>
+                </a:solidFill>
+              </a:defRPr>
+            </a:pPr>
+            <a:r>
+              <a:t>Summary dashboard with 8 key metrics</a:t>
+            </a:r>
+          </a:p>
+          <a:p>
+            <a:pPr>
+              <a:spcBef>
+                <a:spcPts val="600"/>
+              </a:spcBef>
+              <a:defRPr sz="1300">
+                <a:solidFill>
+                  <a:srgbClr val="CCDDEE"/>
+                </a:solidFill>
+              </a:defRPr>
+            </a:pPr>
+            <a:r>
+              <a:t>Messages tab: per-message severity badges</a:t>
+            </a:r>
+          </a:p>
+          <a:p>
+            <a:pPr>
+              <a:spcBef>
+                <a:spcPts val="600"/>
+              </a:spcBef>
+              <a:defRPr sz="1300">
+                <a:solidFill>
+                  <a:srgbClr val="CCDDEE"/>
+                </a:solidFill>
+              </a:defRPr>
+            </a:pPr>
+            <a:r>
+              <a:t>Timeline: visual attack window identification</a:t>
+            </a:r>
+          </a:p>
+          <a:p>
+            <a:pPr>
+              <a:spcBef>
+                <a:spcPts val="600"/>
+              </a:spcBef>
+              <a:defRPr sz="1300">
+                <a:solidFill>
+                  <a:srgbClr val="CCDDEE"/>
+                </a:solidFill>
+              </a:defRPr>
+            </a:pPr>
+            <a:r>
+              <a:t>Per-ID: statistical profile per ECU</a:t>
+            </a:r>
+          </a:p>
+          <a:p>
+            <a:pPr>
+              <a:spcBef>
+                <a:spcPts val="400"/>
+              </a:spcBef>
+            </a:pPr>
+          </a:p>
+          <a:p>
+            <a:pPr>
+              <a:spcBef>
+                <a:spcPts val="1400"/>
+              </a:spcBef>
+              <a:defRPr sz="1600" b="1">
+                <a:solidFill>
+                  <a:srgbClr val="FFFFFF"/>
+                </a:solidFill>
+              </a:defRPr>
+            </a:pPr>
+            <a:r>
+              <a:t>Step 4: Export &amp; Act</a:t>
+            </a:r>
+          </a:p>
+          <a:p>
+            <a:pPr>
+              <a:spcBef>
+                <a:spcPts val="600"/>
+              </a:spcBef>
+              <a:defRPr sz="1300">
+                <a:solidFill>
+                  <a:srgbClr val="CCDDEE"/>
+                </a:solidFill>
+              </a:defRPr>
+            </a:pPr>
+            <a:r>
+              <a:t>Download CSV/JSON/TXT reports</a:t>
+            </a:r>
+          </a:p>
+          <a:p>
+            <a:pPr>
+              <a:spcBef>
+                <a:spcPts val="600"/>
+              </a:spcBef>
+              <a:defRPr sz="1300">
+                <a:solidFill>
+                  <a:srgbClr val="CCDDEE"/>
+                </a:solidFill>
+              </a:defRPr>
+            </a:pPr>
+            <a:r>
+              <a:t>Follow automated diagnostic recommendations</a:t>
+            </a:r>
+          </a:p>
+        </p:txBody>
+      </p:sp>
+      <p:sp>
+        <p:nvSpPr>
+          <p:cNvPr id="6" name="Rectangle 5"/>
+          <p:cNvSpPr/>
+          <p:nvPr/>
+        </p:nvSpPr>
+        <p:spPr>
+          <a:xfrm>
+            <a:off x="0" y="6720840"/>
+            <a:ext cx="9144000" cy="137160"/>
+          </a:xfrm>
+          <a:prstGeom prst="rect">
+            <a:avLst/>
+          </a:prstGeom>
+          <a:solidFill>
+            <a:srgbClr val="0056B3"/>
+          </a:solidFill>
+          <a:ln>
+            <a:noFill/>
+          </a:ln>
+        </p:spPr>
+        <p:style>
+          <a:lnRef idx="1">
+            <a:schemeClr val="accent1"/>
+          </a:lnRef>
+          <a:fillRef idx="3">
+            <a:schemeClr val="accent1"/>
+          </a:fillRef>
+          <a:effectRef idx="2">
+            <a:schemeClr val="accent1"/>
+          </a:effectRef>
+          <a:fontRef idx="minor">
+            <a:schemeClr val="lt1"/>
+          </a:fontRef>
+        </p:style>
+        <p:txBody>
+          <a:bodyPr rtlCol="0" anchor="ctr"/>
+          <a:lstStyle/>
+          <a:p>
+            <a:pPr algn="ctr"/>
+          </a:p>
+        </p:txBody>
+      </p:sp>
+    </p:spTree>
+  </p:cSld>
+  <p:clrMapOvr>
+    <a:masterClrMapping/>
+  </p:clrMapOvr>
+</p:sld>
+</file>
+
+<file path=ppt/slides/slide5.xml><?xml version="1.0" encoding="utf-8"?>
+<p:sld xmlns:a="http://schemas.openxmlformats.org/drawingml/2006/main" xmlns:p="http://schemas.openxmlformats.org/presentationml/2006/main" xmlns:r="http://schemas.openxmlformats.org/officeDocument/2006/relationships">
+  <p:cSld>
+    <p:bg>
+      <p:bgPr>
+        <a:solidFill>
+          <a:srgbClr val="0F1419"/>
+        </a:solidFill>
+        <a:effectLst/>
+      </p:bgPr>
+    </p:bg>
+    <p:spTree>
+      <p:nvGrpSpPr>
+        <p:cNvPr id="1" name=""/>
+        <p:cNvGrpSpPr/>
+        <p:nvPr/>
+      </p:nvGrpSpPr>
+      <p:grpSpPr/>
+      <p:sp>
+        <p:nvSpPr>
+          <p:cNvPr id="2" name="Rectangle 1"/>
+          <p:cNvSpPr/>
+          <p:nvPr/>
+        </p:nvSpPr>
+        <p:spPr>
+          <a:xfrm>
+            <a:off x="0" y="0"/>
+            <a:ext cx="9144000" cy="73152"/>
+          </a:xfrm>
+          <a:prstGeom prst="rect">
+            <a:avLst/>
+          </a:prstGeom>
+          <a:solidFill>
+            <a:srgbClr val="00D4FF"/>
+          </a:solidFill>
+          <a:ln>
+            <a:noFill/>
+          </a:ln>
+        </p:spPr>
+        <p:style>
+          <a:lnRef idx="1">
+            <a:schemeClr val="accent1"/>
+          </a:lnRef>
+          <a:fillRef idx="3">
+            <a:schemeClr val="accent1"/>
+          </a:fillRef>
+          <a:effectRef idx="2">
+            <a:schemeClr val="accent1"/>
+          </a:effectRef>
+          <a:fontRef idx="minor">
+            <a:schemeClr val="lt1"/>
+          </a:fontRef>
+        </p:style>
+        <p:txBody>
+          <a:bodyPr rtlCol="0" anchor="ctr"/>
+          <a:lstStyle/>
+          <a:p>
+            <a:pPr algn="ctr"/>
+          </a:p>
+        </p:txBody>
+      </p:sp>
+      <p:sp>
+        <p:nvSpPr>
+          <p:cNvPr id="3" name="TextBox 2"/>
+          <p:cNvSpPr txBox="1"/>
+          <p:nvPr/>
+        </p:nvSpPr>
+        <p:spPr>
+          <a:xfrm>
+            <a:off x="731520" y="365760"/>
+            <a:ext cx="7772400" cy="731520"/>
+          </a:xfrm>
+          <a:prstGeom prst="rect">
+            <a:avLst/>
+          </a:prstGeom>
+          <a:noFill/>
+        </p:spPr>
+        <p:txBody>
+          <a:bodyPr wrap="square">
+            <a:spAutoFit/>
+          </a:bodyPr>
+          <a:lstStyle/>
+          <a:p>
+            <a:pPr>
+              <a:defRPr sz="2800" b="1">
+                <a:solidFill>
+                  <a:srgbClr val="00D4FF"/>
+                </a:solidFill>
+              </a:defRPr>
+            </a:pPr>
+            <a:r>
+              <a:t>Attack Pattern Detection</a:t>
+            </a:r>
+          </a:p>
+        </p:txBody>
+      </p:sp>
+      <p:sp>
+        <p:nvSpPr>
+          <p:cNvPr id="4" name="TextBox 3"/>
+          <p:cNvSpPr txBox="1"/>
+          <p:nvPr/>
+        </p:nvSpPr>
+        <p:spPr>
+          <a:xfrm>
+            <a:off x="731520" y="1097280"/>
+            <a:ext cx="7772400" cy="457200"/>
+          </a:xfrm>
+          <a:prstGeom prst="rect">
+            <a:avLst/>
+          </a:prstGeom>
+          <a:noFill/>
+        </p:spPr>
+        <p:txBody>
+          <a:bodyPr wrap="none">
+            <a:spAutoFit/>
+          </a:bodyPr>
+          <a:lstStyle/>
+          <a:p>
+            <a:pPr>
+              <a:defRPr sz="1400">
+                <a:solidFill>
+                  <a:srgbClr val="8899A6"/>
+                </a:solidFill>
+              </a:defRPr>
+            </a:pPr>
+            <a:r>
+              <a:t>What the tool finds across different threat scenarios</a:t>
+            </a:r>
+          </a:p>
+        </p:txBody>
+      </p:sp>
+      <p:sp>
+        <p:nvSpPr>
+          <p:cNvPr id="5" name="TextBox 4"/>
+          <p:cNvSpPr txBox="1"/>
+          <p:nvPr/>
+        </p:nvSpPr>
+        <p:spPr>
+          <a:xfrm>
+            <a:off x="731520" y="1737360"/>
+            <a:ext cx="7680960" cy="4572000"/>
+          </a:xfrm>
+          <a:prstGeom prst="rect">
+            <a:avLst/>
+          </a:prstGeom>
+          <a:noFill/>
+        </p:spPr>
+        <p:txBody>
+          <a:bodyPr wrap="square">
+            <a:spAutoFit/>
+          </a:bodyPr>
+          <a:lstStyle/>
+          <a:p>
+            <a:pPr>
+              <a:spcBef>
+                <a:spcPts val="1400"/>
+              </a:spcBef>
+              <a:defRPr sz="1600" b="1">
+                <a:solidFill>
+                  <a:srgbClr val="FFFFFF"/>
+                </a:solidFill>
+              </a:defRPr>
+            </a:pPr>
+            <a:r>
+              <a:t>Single-ID Injection</a:t>
+            </a:r>
+          </a:p>
+          <a:p>
+            <a:pPr>
+              <a:spcBef>
+                <a:spcPts val="600"/>
+              </a:spcBef>
+              <a:defRPr sz="1300">
+                <a:solidFill>
+                  <a:srgbClr val="CCDDEE"/>
+                </a:solidFill>
+              </a:defRPr>
+            </a:pPr>
+            <a:r>
+              <a:t>One CAN ID flooded with rapid messages (&lt; 1ms intervals)</a:t>
+            </a:r>
+          </a:p>
+          <a:p>
+            <a:pPr>
+              <a:spcBef>
+                <a:spcPts val="600"/>
+              </a:spcBef>
+              <a:defRPr sz="1300">
+                <a:solidFill>
+                  <a:srgbClr val="CCDDEE"/>
+                </a:solidFill>
+              </a:defRPr>
+            </a:pPr>
+            <a:r>
+              <a:t>Tool: flags as SPOOFED, shows exact attack window</a:t>
+            </a:r>
+          </a:p>
+          <a:p>
+            <a:pPr>
+              <a:spcBef>
+                <a:spcPts val="400"/>
+              </a:spcBef>
+            </a:pPr>
+          </a:p>
+          <a:p>
+            <a:pPr>
+              <a:spcBef>
+                <a:spcPts val="1400"/>
+              </a:spcBef>
+              <a:defRPr sz="1600" b="1">
+                <a:solidFill>
+                  <a:srgbClr val="FFFFFF"/>
+                </a:solidFill>
+              </a:defRPr>
+            </a:pPr>
+            <a:r>
+              <a:t>Multi-ID Coordinated Attack</a:t>
+            </a:r>
+          </a:p>
+          <a:p>
+            <a:pPr>
+              <a:spcBef>
+                <a:spcPts val="600"/>
+              </a:spcBef>
+              <a:defRPr sz="1300">
+                <a:solidFill>
+                  <a:srgbClr val="CCDDEE"/>
+                </a:solidFill>
+              </a:defRPr>
+            </a:pPr>
+            <a:r>
+              <a:t>Multiple IDs attacked simultaneously from single source</a:t>
+            </a:r>
+          </a:p>
+          <a:p>
+            <a:pPr>
+              <a:spcBef>
+                <a:spcPts val="600"/>
+              </a:spcBef>
+              <a:defRPr sz="1300">
+                <a:solidFill>
+                  <a:srgbClr val="CCDDEE"/>
+                </a:solidFill>
+              </a:defRPr>
+            </a:pPr>
+            <a:r>
+              <a:t>Tool: identifies all affected IDs, correlates timing</a:t>
+            </a:r>
+          </a:p>
+          <a:p>
+            <a:pPr>
+              <a:spcBef>
+                <a:spcPts val="400"/>
+              </a:spcBef>
+            </a:pPr>
+          </a:p>
+          <a:p>
+            <a:pPr>
+              <a:spcBef>
+                <a:spcPts val="1400"/>
+              </a:spcBef>
+              <a:defRPr sz="1600" b="1">
+                <a:solidFill>
+                  <a:srgbClr val="FFFFFF"/>
+                </a:solidFill>
+              </a:defRPr>
+            </a:pPr>
+            <a:r>
+              <a:t>Denial of Service Flood</a:t>
+            </a:r>
+          </a:p>
+          <a:p>
+            <a:pPr>
+              <a:spcBef>
+                <a:spcPts val="600"/>
+              </a:spcBef>
+              <a:defRPr sz="1300">
+                <a:solidFill>
+                  <a:srgbClr val="CCDDEE"/>
+                </a:solidFill>
+              </a:defRPr>
+            </a:pPr>
+            <a:r>
+              <a:t>High-priority IDs (0x000-0x00F) at maximum bus rate</a:t>
+            </a:r>
+          </a:p>
+          <a:p>
+            <a:pPr>
+              <a:spcBef>
+                <a:spcPts val="600"/>
+              </a:spcBef>
+              <a:defRPr sz="1300">
+                <a:solidFill>
+                  <a:srgbClr val="CCDDEE"/>
+                </a:solidFill>
+              </a:defRPr>
+            </a:pPr>
+            <a:r>
+              <a:t>Tool: detects extreme message rate and near-zero deltas</a:t>
+            </a:r>
+          </a:p>
+          <a:p>
+            <a:pPr>
+              <a:spcBef>
+                <a:spcPts val="400"/>
+              </a:spcBef>
+            </a:pPr>
+          </a:p>
+          <a:p>
+            <a:pPr>
+              <a:spcBef>
+                <a:spcPts val="1400"/>
+              </a:spcBef>
+              <a:defRPr sz="1600" b="1">
+                <a:solidFill>
+                  <a:srgbClr val="FFFFFF"/>
+                </a:solidFill>
+              </a:defRPr>
+            </a:pPr>
+            <a:r>
+              <a:t>Replay Attack</a:t>
+            </a:r>
+          </a:p>
+          <a:p>
+            <a:pPr>
+              <a:spcBef>
+                <a:spcPts val="600"/>
+              </a:spcBef>
+              <a:defRPr sz="1300">
+                <a:solidFill>
+                  <a:srgbClr val="CCDDEE"/>
+                </a:solidFill>
+              </a:defRPr>
+            </a:pPr>
+            <a:r>
+              <a:t>Legitimate data replayed at elevated frequency</a:t>
+            </a:r>
+          </a:p>
+          <a:p>
+            <a:pPr>
+              <a:spcBef>
+                <a:spcPts val="600"/>
+              </a:spcBef>
+              <a:defRPr sz="1300">
+                <a:solidFill>
+                  <a:srgbClr val="CCDDEE"/>
+                </a:solidFill>
+              </a:defRPr>
+            </a:pPr>
+            <a:r>
+              <a:t>Tool: catches timing anomaly despite realistic payloads</a:t>
+            </a:r>
+          </a:p>
+          <a:p>
+            <a:pPr>
+              <a:spcBef>
+                <a:spcPts val="400"/>
+              </a:spcBef>
+            </a:pPr>
+          </a:p>
+          <a:p>
+            <a:pPr>
+              <a:spcBef>
+                <a:spcPts val="1400"/>
+              </a:spcBef>
+              <a:defRPr sz="1600" b="1">
+                <a:solidFill>
+                  <a:srgbClr val="FFFFFF"/>
+                </a:solidFill>
+              </a:defRPr>
+            </a:pPr>
+            <a:r>
+              <a:t>Intermittent Stealth Attack</a:t>
+            </a:r>
+          </a:p>
+          <a:p>
+            <a:pPr>
+              <a:spcBef>
+                <a:spcPts val="600"/>
+              </a:spcBef>
+              <a:defRPr sz="1300">
+                <a:solidFill>
+                  <a:srgbClr val="CCDDEE"/>
+                </a:solidFill>
+              </a:defRPr>
+            </a:pPr>
+            <a:r>
+              <a:t>Short periodic bursts designed to evade detection</a:t>
+            </a:r>
+          </a:p>
+          <a:p>
+            <a:pPr>
+              <a:spcBef>
+                <a:spcPts val="600"/>
+              </a:spcBef>
+              <a:defRPr sz="1300">
+                <a:solidFill>
+                  <a:srgbClr val="CCDDEE"/>
+                </a:solidFill>
+              </a:defRPr>
+            </a:pPr>
+            <a:r>
+              <a:t>Tool: statistical profiling catches std dev anomalies</a:t>
+            </a:r>
+          </a:p>
+        </p:txBody>
+      </p:sp>
+      <p:sp>
+        <p:nvSpPr>
+          <p:cNvPr id="6" name="Rectangle 5"/>
+          <p:cNvSpPr/>
+          <p:nvPr/>
+        </p:nvSpPr>
+        <p:spPr>
+          <a:xfrm>
+            <a:off x="0" y="6720840"/>
+            <a:ext cx="9144000" cy="137160"/>
+          </a:xfrm>
+          <a:prstGeom prst="rect">
+            <a:avLst/>
+          </a:prstGeom>
+          <a:solidFill>
+            <a:srgbClr val="0056B3"/>
+          </a:solidFill>
+          <a:ln>
+            <a:noFill/>
+          </a:ln>
+        </p:spPr>
+        <p:style>
+          <a:lnRef idx="1">
+            <a:schemeClr val="accent1"/>
+          </a:lnRef>
+          <a:fillRef idx="3">
+            <a:schemeClr val="accent1"/>
+          </a:fillRef>
+          <a:effectRef idx="2">
+            <a:schemeClr val="accent1"/>
+          </a:effectRef>
+          <a:fontRef idx="minor">
+            <a:schemeClr val="lt1"/>
+          </a:fontRef>
+        </p:style>
+        <p:txBody>
+          <a:bodyPr rtlCol="0" anchor="ctr"/>
+          <a:lstStyle/>
+          <a:p>
+            <a:pPr algn="ctr"/>
+          </a:p>
+        </p:txBody>
+      </p:sp>
+    </p:spTree>
+  </p:cSld>
+  <p:clrMapOvr>
+    <a:masterClrMapping/>
+  </p:clrMapOvr>
+</p:sld>
+</file>
+
+<file path=ppt/slides/slide6.xml><?xml version="1.0" encoding="utf-8"?>
+<p:sld xmlns:a="http://schemas.openxmlformats.org/drawingml/2006/main" xmlns:p="http://schemas.openxmlformats.org/presentationml/2006/main" xmlns:r="http://schemas.openxmlformats.org/officeDocument/2006/relationships">
+  <p:cSld>
+    <p:bg>
+      <p:bgPr>
+        <a:solidFill>
+          <a:srgbClr val="0F1419"/>
+        </a:solidFill>
+        <a:effectLst/>
+      </p:bgPr>
+    </p:bg>
+    <p:spTree>
+      <p:nvGrpSpPr>
+        <p:cNvPr id="1" name=""/>
+        <p:cNvGrpSpPr/>
+        <p:nvPr/>
+      </p:nvGrpSpPr>
+      <p:grpSpPr/>
+      <p:sp>
+        <p:nvSpPr>
+          <p:cNvPr id="2" name="Rectangle 1"/>
+          <p:cNvSpPr/>
+          <p:nvPr/>
+        </p:nvSpPr>
+        <p:spPr>
+          <a:xfrm>
+            <a:off x="0" y="0"/>
+            <a:ext cx="9144000" cy="73152"/>
+          </a:xfrm>
+          <a:prstGeom prst="rect">
+            <a:avLst/>
+          </a:prstGeom>
+          <a:solidFill>
+            <a:srgbClr val="00D4FF"/>
+          </a:solidFill>
+          <a:ln>
+            <a:noFill/>
+          </a:ln>
+        </p:spPr>
+        <p:style>
+          <a:lnRef idx="1">
+            <a:schemeClr val="accent1"/>
+          </a:lnRef>
+          <a:fillRef idx="3">
+            <a:schemeClr val="accent1"/>
+          </a:fillRef>
+          <a:effectRef idx="2">
+            <a:schemeClr val="accent1"/>
+          </a:effectRef>
+          <a:fontRef idx="minor">
+            <a:schemeClr val="lt1"/>
+          </a:fontRef>
+        </p:style>
+        <p:txBody>
+          <a:bodyPr rtlCol="0" anchor="ctr"/>
+          <a:lstStyle/>
+          <a:p>
+            <a:pPr algn="ctr"/>
+          </a:p>
+        </p:txBody>
+      </p:sp>
+      <p:sp>
+        <p:nvSpPr>
+          <p:cNvPr id="3" name="TextBox 2"/>
+          <p:cNvSpPr txBox="1"/>
+          <p:nvPr/>
+        </p:nvSpPr>
+        <p:spPr>
+          <a:xfrm>
+            <a:off x="731520" y="365760"/>
+            <a:ext cx="7772400" cy="731520"/>
+          </a:xfrm>
+          <a:prstGeom prst="rect">
+            <a:avLst/>
+          </a:prstGeom>
+          <a:noFill/>
+        </p:spPr>
+        <p:txBody>
+          <a:bodyPr wrap="square">
+            <a:spAutoFit/>
+          </a:bodyPr>
+          <a:lstStyle/>
+          <a:p>
+            <a:pPr>
+              <a:defRPr sz="2800" b="1">
+                <a:solidFill>
+                  <a:srgbClr val="00D4FF"/>
+                </a:solidFill>
+              </a:defRPr>
+            </a:pPr>
+            <a:r>
+              <a:t>Professional User Interface</a:t>
+            </a:r>
+          </a:p>
+        </p:txBody>
+      </p:sp>
+      <p:sp>
+        <p:nvSpPr>
+          <p:cNvPr id="4" name="TextBox 3"/>
+          <p:cNvSpPr txBox="1"/>
+          <p:nvPr/>
+        </p:nvSpPr>
+        <p:spPr>
+          <a:xfrm>
+            <a:off x="731520" y="1097280"/>
+            <a:ext cx="7772400" cy="457200"/>
+          </a:xfrm>
+          <a:prstGeom prst="rect">
+            <a:avLst/>
+          </a:prstGeom>
+          <a:noFill/>
+        </p:spPr>
+        <p:txBody>
+          <a:bodyPr wrap="none">
+            <a:spAutoFit/>
+          </a:bodyPr>
+          <a:lstStyle/>
+          <a:p>
+            <a:pPr>
+              <a:defRPr sz="1400">
+                <a:solidFill>
+                  <a:srgbClr val="8899A6"/>
+                </a:solidFill>
+              </a:defRPr>
+            </a:pPr>
+            <a:r>
+              <a:t>Dark-themed engineering dashboard with full diagnostic capabilities</a:t>
+            </a:r>
+          </a:p>
+        </p:txBody>
+      </p:sp>
+      <p:sp>
+        <p:nvSpPr>
+          <p:cNvPr id="5" name="TextBox 4"/>
+          <p:cNvSpPr txBox="1"/>
+          <p:nvPr/>
+        </p:nvSpPr>
+        <p:spPr>
+          <a:xfrm>
+            <a:off x="731520" y="1737360"/>
+            <a:ext cx="7680960" cy="4572000"/>
+          </a:xfrm>
+          <a:prstGeom prst="rect">
+            <a:avLst/>
+          </a:prstGeom>
+          <a:noFill/>
+        </p:spPr>
+        <p:txBody>
+          <a:bodyPr wrap="square">
+            <a:spAutoFit/>
+          </a:bodyPr>
+          <a:lstStyle/>
+          <a:p>
+            <a:pPr>
+              <a:spcBef>
+                <a:spcPts val="1400"/>
+              </a:spcBef>
+              <a:defRPr sz="1600" b="1">
+                <a:solidFill>
+                  <a:srgbClr val="FFFFFF"/>
+                </a:solidFill>
+              </a:defRPr>
+            </a:pPr>
+            <a:r>
+              <a:t>Dashboard Components</a:t>
+            </a:r>
+          </a:p>
+          <a:p>
+            <a:pPr>
+              <a:spcBef>
+                <a:spcPts val="600"/>
+              </a:spcBef>
+              <a:defRPr sz="1300">
+                <a:solidFill>
+                  <a:srgbClr val="CCDDEE"/>
+                </a:solidFill>
+              </a:defRPr>
+            </a:pPr>
+            <a:r>
+              <a:t>8 real-time summary statistics with color coding</a:t>
+            </a:r>
+          </a:p>
+          <a:p>
+            <a:pPr>
+              <a:spcBef>
+                <a:spcPts val="600"/>
+              </a:spcBef>
+              <a:defRPr sz="1300">
+                <a:solidFill>
+                  <a:srgbClr val="CCDDEE"/>
+                </a:solidFill>
+              </a:defRPr>
+            </a:pPr>
+            <a:r>
+              <a:t>Network health progress bar (Good / Degraded / Under Attack)</a:t>
+            </a:r>
+          </a:p>
+          <a:p>
+            <a:pPr>
+              <a:spcBef>
+                <a:spcPts val="600"/>
+              </a:spcBef>
+              <a:defRPr sz="1300">
+                <a:solidFill>
+                  <a:srgbClr val="CCDDEE"/>
+                </a:solidFill>
+              </a:defRPr>
+            </a:pPr>
+            <a:r>
+              <a:t>Configurable analysis parameters (6 settings)</a:t>
+            </a:r>
+          </a:p>
+          <a:p>
+            <a:pPr>
+              <a:spcBef>
+                <a:spcPts val="600"/>
+              </a:spcBef>
+              <a:defRPr sz="1300">
+                <a:solidFill>
+                  <a:srgbClr val="CCDDEE"/>
+                </a:solidFill>
+              </a:defRPr>
+            </a:pPr>
+            <a:r>
+              <a:t>Drag &amp; drop file zone with format auto-detection</a:t>
+            </a:r>
+          </a:p>
+          <a:p>
+            <a:pPr>
+              <a:spcBef>
+                <a:spcPts val="400"/>
+              </a:spcBef>
+            </a:pPr>
+          </a:p>
+          <a:p>
+            <a:pPr>
+              <a:spcBef>
+                <a:spcPts val="1400"/>
+              </a:spcBef>
+              <a:defRPr sz="1600" b="1">
+                <a:solidFill>
+                  <a:srgbClr val="FFFFFF"/>
+                </a:solidFill>
+              </a:defRPr>
+            </a:pPr>
+            <a:r>
+              <a:t>Results Presentation</a:t>
+            </a:r>
+          </a:p>
+          <a:p>
+            <a:pPr>
+              <a:spcBef>
+                <a:spcPts val="600"/>
+              </a:spcBef>
+              <a:defRPr sz="1300">
+                <a:solidFill>
+                  <a:srgbClr val="CCDDEE"/>
+                </a:solidFill>
+              </a:defRPr>
+            </a:pPr>
+            <a:r>
+              <a:t>Tabbed interface: Messages | Timeline | Per-ID | Export</a:t>
+            </a:r>
+          </a:p>
+          <a:p>
+            <a:pPr>
+              <a:spcBef>
+                <a:spcPts val="600"/>
+              </a:spcBef>
+              <a:defRPr sz="1300">
+                <a:solidFill>
+                  <a:srgbClr val="CCDDEE"/>
+                </a:solidFill>
+              </a:defRPr>
+            </a:pPr>
+            <a:r>
+              <a:t>Color-coded severity badges: Green / Yellow / Red</a:t>
+            </a:r>
+          </a:p>
+          <a:p>
+            <a:pPr>
+              <a:spcBef>
+                <a:spcPts val="600"/>
+              </a:spcBef>
+              <a:defRPr sz="1300">
+                <a:solidFill>
+                  <a:srgbClr val="CCDDEE"/>
+                </a:solidFill>
+              </a:defRPr>
+            </a:pPr>
+            <a:r>
+              <a:t>Interactive timeline per CAN ID showing attack windows</a:t>
+            </a:r>
+          </a:p>
+          <a:p>
+            <a:pPr>
+              <a:spcBef>
+                <a:spcPts val="600"/>
+              </a:spcBef>
+              <a:defRPr sz="1300">
+                <a:solidFill>
+                  <a:srgbClr val="CCDDEE"/>
+                </a:solidFill>
+              </a:defRPr>
+            </a:pPr>
+            <a:r>
+              <a:t>Scrollable tables with sortable columns</a:t>
+            </a:r>
+          </a:p>
+          <a:p>
+            <a:pPr>
+              <a:spcBef>
+                <a:spcPts val="400"/>
+              </a:spcBef>
+            </a:pPr>
+          </a:p>
+          <a:p>
+            <a:pPr>
+              <a:spcBef>
+                <a:spcPts val="1400"/>
+              </a:spcBef>
+              <a:defRPr sz="1600" b="1">
+                <a:solidFill>
+                  <a:srgbClr val="FFFFFF"/>
+                </a:solidFill>
+              </a:defRPr>
+            </a:pPr>
+            <a:r>
+              <a:t>Smart Diagnostics</a:t>
+            </a:r>
+          </a:p>
+          <a:p>
+            <a:pPr>
+              <a:spcBef>
+                <a:spcPts val="600"/>
+              </a:spcBef>
+              <a:defRPr sz="1300">
+                <a:solidFill>
+                  <a:srgbClr val="CCDDEE"/>
+                </a:solidFill>
+              </a:defRPr>
+            </a:pPr>
+            <a:r>
+              <a:t>Automated recommendation engine</a:t>
+            </a:r>
+          </a:p>
+          <a:p>
+            <a:pPr>
+              <a:spcBef>
+                <a:spcPts val="600"/>
+              </a:spcBef>
+              <a:defRPr sz="1300">
+                <a:solidFill>
+                  <a:srgbClr val="CCDDEE"/>
+                </a:solidFill>
+              </a:defRPr>
+            </a:pPr>
+            <a:r>
+              <a:t>Actionable steps based on detected patterns</a:t>
+            </a:r>
+          </a:p>
+          <a:p>
+            <a:pPr>
+              <a:spcBef>
+                <a:spcPts val="600"/>
+              </a:spcBef>
+              <a:defRPr sz="1300">
+                <a:solidFill>
+                  <a:srgbClr val="CCDDEE"/>
+                </a:solidFill>
+              </a:defRPr>
+            </a:pPr>
+            <a:r>
+              <a:t>Network health percentage with status classification</a:t>
+            </a:r>
+          </a:p>
+        </p:txBody>
+      </p:sp>
+      <p:sp>
+        <p:nvSpPr>
+          <p:cNvPr id="6" name="Rectangle 5"/>
+          <p:cNvSpPr/>
+          <p:nvPr/>
+        </p:nvSpPr>
+        <p:spPr>
+          <a:xfrm>
+            <a:off x="0" y="6720840"/>
+            <a:ext cx="9144000" cy="137160"/>
+          </a:xfrm>
+          <a:prstGeom prst="rect">
+            <a:avLst/>
+          </a:prstGeom>
+          <a:solidFill>
+            <a:srgbClr val="0056B3"/>
+          </a:solidFill>
+          <a:ln>
+            <a:noFill/>
+          </a:ln>
+        </p:spPr>
+        <p:style>
+          <a:lnRef idx="1">
+            <a:schemeClr val="accent1"/>
+          </a:lnRef>
+          <a:fillRef idx="3">
+            <a:schemeClr val="accent1"/>
+          </a:fillRef>
+          <a:effectRef idx="2">
+            <a:schemeClr val="accent1"/>
+          </a:effectRef>
+          <a:fontRef idx="minor">
+            <a:schemeClr val="lt1"/>
+          </a:fontRef>
+        </p:style>
+        <p:txBody>
+          <a:bodyPr rtlCol="0" anchor="ctr"/>
+          <a:lstStyle/>
+          <a:p>
+            <a:pPr algn="ctr"/>
+          </a:p>
+        </p:txBody>
+      </p:sp>
+    </p:spTree>
+  </p:cSld>
+  <p:clrMapOvr>
+    <a:masterClrMapping/>
+  </p:clrMapOvr>
+</p:sld>
+</file>
+
+<file path=ppt/slides/slide7.xml><?xml version="1.0" encoding="utf-8"?>
+<p:sld xmlns:a="http://schemas.openxmlformats.org/drawingml/2006/main" xmlns:p="http://schemas.openxmlformats.org/presentationml/2006/main" xmlns:r="http://schemas.openxmlformats.org/officeDocument/2006/relationships">
+  <p:cSld>
+    <p:bg>
+      <p:bgPr>
+        <a:solidFill>
+          <a:srgbClr val="0F1419"/>
+        </a:solidFill>
+        <a:effectLst/>
+      </p:bgPr>
+    </p:bg>
+    <p:spTree>
+      <p:nvGrpSpPr>
+        <p:cNvPr id="1" name=""/>
+        <p:cNvGrpSpPr/>
+        <p:nvPr/>
+      </p:nvGrpSpPr>
+      <p:grpSpPr/>
+      <p:sp>
+        <p:nvSpPr>
+          <p:cNvPr id="2" name="Rectangle 1"/>
+          <p:cNvSpPr/>
+          <p:nvPr/>
+        </p:nvSpPr>
+        <p:spPr>
+          <a:xfrm>
+            <a:off x="0" y="0"/>
+            <a:ext cx="9144000" cy="73152"/>
+          </a:xfrm>
+          <a:prstGeom prst="rect">
+            <a:avLst/>
+          </a:prstGeom>
+          <a:solidFill>
+            <a:srgbClr val="00D4FF"/>
+          </a:solidFill>
+          <a:ln>
+            <a:noFill/>
+          </a:ln>
+        </p:spPr>
+        <p:style>
+          <a:lnRef idx="1">
+            <a:schemeClr val="accent1"/>
+          </a:lnRef>
+          <a:fillRef idx="3">
+            <a:schemeClr val="accent1"/>
+          </a:fillRef>
+          <a:effectRef idx="2">
+            <a:schemeClr val="accent1"/>
+          </a:effectRef>
+          <a:fontRef idx="minor">
+            <a:schemeClr val="lt1"/>
+          </a:fontRef>
+        </p:style>
+        <p:txBody>
+          <a:bodyPr rtlCol="0" anchor="ctr"/>
+          <a:lstStyle/>
+          <a:p>
+            <a:pPr algn="ctr"/>
+          </a:p>
+        </p:txBody>
+      </p:sp>
+      <p:sp>
+        <p:nvSpPr>
+          <p:cNvPr id="3" name="TextBox 2"/>
+          <p:cNvSpPr txBox="1"/>
+          <p:nvPr/>
+        </p:nvSpPr>
+        <p:spPr>
+          <a:xfrm>
+            <a:off x="731520" y="365760"/>
+            <a:ext cx="7772400" cy="731520"/>
+          </a:xfrm>
+          <a:prstGeom prst="rect">
+            <a:avLst/>
+          </a:prstGeom>
+          <a:noFill/>
+        </p:spPr>
+        <p:txBody>
+          <a:bodyPr wrap="square">
+            <a:spAutoFit/>
+          </a:bodyPr>
+          <a:lstStyle/>
+          <a:p>
+            <a:pPr>
+              <a:defRPr sz="2800" b="1">
+                <a:solidFill>
+                  <a:srgbClr val="00D4FF"/>
+                </a:solidFill>
+              </a:defRPr>
+            </a:pPr>
+            <a:r>
+              <a:t>Comprehensive Test Data Suite</a:t>
+            </a:r>
+          </a:p>
+        </p:txBody>
+      </p:sp>
+      <p:sp>
+        <p:nvSpPr>
+          <p:cNvPr id="4" name="TextBox 3"/>
+          <p:cNvSpPr txBox="1"/>
+          <p:nvPr/>
+        </p:nvSpPr>
+        <p:spPr>
+          <a:xfrm>
+            <a:off x="731520" y="1097280"/>
+            <a:ext cx="7772400" cy="457200"/>
+          </a:xfrm>
+          <a:prstGeom prst="rect">
+            <a:avLst/>
+          </a:prstGeom>
+          <a:noFill/>
+        </p:spPr>
+        <p:txBody>
+          <a:bodyPr wrap="none">
+            <a:spAutoFit/>
+          </a:bodyPr>
+          <a:lstStyle/>
+          <a:p>
+            <a:pPr>
+              <a:defRPr sz="1400">
+                <a:solidFill>
+                  <a:srgbClr val="8899A6"/>
+                </a:solidFill>
+              </a:defRPr>
+            </a:pPr>
+            <a:r>
+              <a:t>10 pre-built scenarios — 18,300+ messages — 752KB+</a:t>
+            </a:r>
+          </a:p>
+        </p:txBody>
+      </p:sp>
+      <p:sp>
+        <p:nvSpPr>
+          <p:cNvPr id="5" name="TextBox 4"/>
+          <p:cNvSpPr txBox="1"/>
+          <p:nvPr/>
+        </p:nvSpPr>
+        <p:spPr>
+          <a:xfrm>
+            <a:off x="731520" y="1737360"/>
+            <a:ext cx="7680960" cy="4572000"/>
+          </a:xfrm>
+          <a:prstGeom prst="rect">
+            <a:avLst/>
+          </a:prstGeom>
+          <a:noFill/>
+        </p:spPr>
+        <p:txBody>
+          <a:bodyPr wrap="square">
+            <a:spAutoFit/>
+          </a:bodyPr>
+          <a:lstStyle/>
+          <a:p>
+            <a:pPr>
+              <a:spcBef>
+                <a:spcPts val="1400"/>
+              </a:spcBef>
+              <a:defRPr sz="1600" b="1">
+                <a:solidFill>
+                  <a:srgbClr val="FFFFFF"/>
+                </a:solidFill>
+              </a:defRPr>
+            </a:pPr>
+            <a:r>
+              <a:t>Included Test Scenarios</a:t>
+            </a:r>
+          </a:p>
+          <a:p>
+            <a:pPr>
+              <a:spcBef>
+                <a:spcPts val="600"/>
+              </a:spcBef>
+              <a:defRPr sz="1300">
+                <a:solidFill>
+                  <a:srgbClr val="CCDDEE"/>
+                </a:solidFill>
+              </a:defRPr>
+            </a:pPr>
+            <a:r>
+              <a:t>01: Normal traffic (500 msg) — clean baseline</a:t>
+            </a:r>
+          </a:p>
+          <a:p>
+            <a:pPr>
+              <a:spcBef>
+                <a:spcPts val="600"/>
+              </a:spcBef>
+              <a:defRPr sz="1300">
+                <a:solidFill>
+                  <a:srgbClr val="CCDDEE"/>
+                </a:solidFill>
+              </a:defRPr>
+            </a:pPr>
+            <a:r>
+              <a:t>02: Single-ID injection (800 msg) — targeted attack</a:t>
+            </a:r>
+          </a:p>
+          <a:p>
+            <a:pPr>
+              <a:spcBef>
+                <a:spcPts val="600"/>
+              </a:spcBef>
+              <a:defRPr sz="1300">
+                <a:solidFill>
+                  <a:srgbClr val="CCDDEE"/>
+                </a:solidFill>
+              </a:defRPr>
+            </a:pPr>
+            <a:r>
+              <a:t>03: Multi-ID coordinated (1,200 msg) — advanced threat</a:t>
+            </a:r>
+          </a:p>
+          <a:p>
+            <a:pPr>
+              <a:spcBef>
+                <a:spcPts val="600"/>
+              </a:spcBef>
+              <a:defRPr sz="1300">
+                <a:solidFill>
+                  <a:srgbClr val="CCDDEE"/>
+                </a:solidFill>
+              </a:defRPr>
+            </a:pPr>
+            <a:r>
+              <a:t>04: Replay attack (1,000 msg) — captured pattern replay</a:t>
+            </a:r>
+          </a:p>
+          <a:p>
+            <a:pPr>
+              <a:spcBef>
+                <a:spcPts val="600"/>
+              </a:spcBef>
+              <a:defRPr sz="1300">
+                <a:solidFill>
+                  <a:srgbClr val="CCDDEE"/>
+                </a:solidFill>
+              </a:defRPr>
+            </a:pPr>
+            <a:r>
+              <a:t>05: 25-ECU stress test (3,000 msg) — high-complexity</a:t>
+            </a:r>
+          </a:p>
+          <a:p>
+            <a:pPr>
+              <a:spcBef>
+                <a:spcPts val="600"/>
+              </a:spcBef>
+              <a:defRPr sz="1300">
+                <a:solidFill>
+                  <a:srgbClr val="CCDDEE"/>
+                </a:solidFill>
+              </a:defRPr>
+            </a:pPr>
+            <a:r>
+              <a:t>06: DoS flood (2,000 msg) — denial of service</a:t>
+            </a:r>
+          </a:p>
+          <a:p>
+            <a:pPr>
+              <a:spcBef>
+                <a:spcPts val="600"/>
+              </a:spcBef>
+              <a:defRPr sz="1300">
+                <a:solidFill>
+                  <a:srgbClr val="CCDDEE"/>
+                </a:solidFill>
+              </a:defRPr>
+            </a:pPr>
+            <a:r>
+              <a:t>07: CSV format (800 msg) — format validation</a:t>
+            </a:r>
+          </a:p>
+          <a:p>
+            <a:pPr>
+              <a:spcBef>
+                <a:spcPts val="600"/>
+              </a:spcBef>
+              <a:defRPr sz="1300">
+                <a:solidFill>
+                  <a:srgbClr val="CCDDEE"/>
+                </a:solidFill>
+              </a:defRPr>
+            </a:pPr>
+            <a:r>
+              <a:t>08: Vector ASC format (1,500 msg) — industry standard</a:t>
+            </a:r>
+          </a:p>
+          <a:p>
+            <a:pPr>
+              <a:spcBef>
+                <a:spcPts val="600"/>
+              </a:spcBef>
+              <a:defRPr sz="1300">
+                <a:solidFill>
+                  <a:srgbClr val="CCDDEE"/>
+                </a:solidFill>
+              </a:defRPr>
+            </a:pPr>
+            <a:r>
+              <a:t>09: Intermittent stealth (2,500 msg) — periodic bursts</a:t>
+            </a:r>
+          </a:p>
+          <a:p>
+            <a:pPr>
+              <a:spcBef>
+                <a:spcPts val="600"/>
+              </a:spcBef>
+              <a:defRPr sz="1300">
+                <a:solidFill>
+                  <a:srgbClr val="CCDDEE"/>
+                </a:solidFill>
+              </a:defRPr>
+            </a:pPr>
+            <a:r>
+              <a:t>10: Realistic 40-ECU (5,000 msg) — full vehicle sim</a:t>
+            </a:r>
+          </a:p>
+          <a:p>
+            <a:pPr>
+              <a:spcBef>
+                <a:spcPts val="400"/>
+              </a:spcBef>
+            </a:pPr>
+          </a:p>
+          <a:p>
+            <a:pPr>
+              <a:spcBef>
+                <a:spcPts val="1400"/>
+              </a:spcBef>
+              <a:defRPr sz="1600" b="1">
+                <a:solidFill>
+                  <a:srgbClr val="FFFFFF"/>
+                </a:solidFill>
+              </a:defRPr>
+            </a:pPr>
+            <a:r>
+              <a:t>Coverage</a:t>
+            </a:r>
+          </a:p>
+          <a:p>
+            <a:pPr>
+              <a:spcBef>
+                <a:spcPts val="600"/>
+              </a:spcBef>
+              <a:defRPr sz="1300">
+                <a:solidFill>
+                  <a:srgbClr val="CCDDEE"/>
+                </a:solidFill>
+              </a:defRPr>
+            </a:pPr>
+            <a:r>
+              <a:t>All major attack types validated</a:t>
+            </a:r>
+          </a:p>
+          <a:p>
+            <a:pPr>
+              <a:spcBef>
+                <a:spcPts val="600"/>
+              </a:spcBef>
+              <a:defRPr sz="1300">
+                <a:solidFill>
+                  <a:srgbClr val="CCDDEE"/>
+                </a:solidFill>
+              </a:defRPr>
+            </a:pPr>
+            <a:r>
+              <a:t>Multiple file formats tested</a:t>
+            </a:r>
+          </a:p>
+          <a:p>
+            <a:pPr>
+              <a:spcBef>
+                <a:spcPts val="600"/>
+              </a:spcBef>
+              <a:defRPr sz="1300">
+                <a:solidFill>
+                  <a:srgbClr val="CCDDEE"/>
+                </a:solidFill>
+              </a:defRPr>
+            </a:pPr>
+            <a:r>
+              <a:t>Scalability proven to 5000+ messages</a:t>
+            </a:r>
+          </a:p>
+        </p:txBody>
+      </p:sp>
+      <p:sp>
+        <p:nvSpPr>
+          <p:cNvPr id="6" name="Rectangle 5"/>
+          <p:cNvSpPr/>
+          <p:nvPr/>
+        </p:nvSpPr>
+        <p:spPr>
+          <a:xfrm>
+            <a:off x="0" y="6720840"/>
+            <a:ext cx="9144000" cy="137160"/>
+          </a:xfrm>
+          <a:prstGeom prst="rect">
+            <a:avLst/>
+          </a:prstGeom>
+          <a:solidFill>
+            <a:srgbClr val="0056B3"/>
+          </a:solidFill>
+          <a:ln>
+            <a:noFill/>
+          </a:ln>
+        </p:spPr>
+        <p:style>
+          <a:lnRef idx="1">
+            <a:schemeClr val="accent1"/>
+          </a:lnRef>
+          <a:fillRef idx="3">
+            <a:schemeClr val="accent1"/>
+          </a:fillRef>
+          <a:effectRef idx="2">
+            <a:schemeClr val="accent1"/>
+          </a:effectRef>
+          <a:fontRef idx="minor">
+            <a:schemeClr val="lt1"/>
+          </a:fontRef>
+        </p:style>
+        <p:txBody>
+          <a:bodyPr rtlCol="0" anchor="ctr"/>
+          <a:lstStyle/>
+          <a:p>
+            <a:pPr algn="ctr"/>
+          </a:p>
+        </p:txBody>
+      </p:sp>
+    </p:spTree>
+  </p:cSld>
+  <p:clrMapOvr>
+    <a:masterClrMapping/>
+  </p:clrMapOvr>
+</p:sld>
+</file>
+
+<file path=ppt/slides/slide8.xml><?xml version="1.0" encoding="utf-8"?>
+<p:sld xmlns:a="http://schemas.openxmlformats.org/drawingml/2006/main" xmlns:p="http://schemas.openxmlformats.org/presentationml/2006/main" xmlns:r="http://schemas.openxmlformats.org/officeDocument/2006/relationships">
+  <p:cSld>
+    <p:bg>
+      <p:bgPr>
+        <a:solidFill>
+          <a:srgbClr val="0F1419"/>
+        </a:solidFill>
+        <a:effectLst/>
+      </p:bgPr>
+    </p:bg>
+    <p:spTree>
+      <p:nvGrpSpPr>
+        <p:cNvPr id="1" name=""/>
+        <p:cNvGrpSpPr/>
+        <p:nvPr/>
+      </p:nvGrpSpPr>
+      <p:grpSpPr/>
+      <p:sp>
+        <p:nvSpPr>
+          <p:cNvPr id="2" name="Rectangle 1"/>
+          <p:cNvSpPr/>
+          <p:nvPr/>
+        </p:nvSpPr>
+        <p:spPr>
+          <a:xfrm>
+            <a:off x="0" y="0"/>
+            <a:ext cx="9144000" cy="73152"/>
+          </a:xfrm>
+          <a:prstGeom prst="rect">
+            <a:avLst/>
+          </a:prstGeom>
+          <a:solidFill>
+            <a:srgbClr val="00D4FF"/>
+          </a:solidFill>
+          <a:ln>
+            <a:noFill/>
+          </a:ln>
+        </p:spPr>
+        <p:style>
+          <a:lnRef idx="1">
+            <a:schemeClr val="accent1"/>
+          </a:lnRef>
+          <a:fillRef idx="3">
+            <a:schemeClr val="accent1"/>
+          </a:fillRef>
+          <a:effectRef idx="2">
+            <a:schemeClr val="accent1"/>
+          </a:effectRef>
+          <a:fontRef idx="minor">
+            <a:schemeClr val="lt1"/>
+          </a:fontRef>
+        </p:style>
+        <p:txBody>
+          <a:bodyPr rtlCol="0" anchor="ctr"/>
+          <a:lstStyle/>
+          <a:p>
+            <a:pPr algn="ctr"/>
+          </a:p>
+        </p:txBody>
+      </p:sp>
+      <p:sp>
+        <p:nvSpPr>
+          <p:cNvPr id="3" name="TextBox 2"/>
+          <p:cNvSpPr txBox="1"/>
+          <p:nvPr/>
+        </p:nvSpPr>
+        <p:spPr>
+          <a:xfrm>
+            <a:off x="731520" y="365760"/>
+            <a:ext cx="7772400" cy="731520"/>
+          </a:xfrm>
+          <a:prstGeom prst="rect">
+            <a:avLst/>
+          </a:prstGeom>
+          <a:noFill/>
+        </p:spPr>
+        <p:txBody>
+          <a:bodyPr wrap="square">
+            <a:spAutoFit/>
+          </a:bodyPr>
+          <a:lstStyle/>
+          <a:p>
+            <a:pPr>
+              <a:defRPr sz="2800" b="1">
+                <a:solidFill>
+                  <a:srgbClr val="00D4FF"/>
+                </a:solidFill>
+              </a:defRPr>
+            </a:pPr>
+            <a:r>
+              <a:t>Future Enhancements</a:t>
+            </a:r>
+          </a:p>
+        </p:txBody>
+      </p:sp>
+      <p:sp>
+        <p:nvSpPr>
+          <p:cNvPr id="4" name="TextBox 3"/>
+          <p:cNvSpPr txBox="1"/>
+          <p:nvPr/>
+        </p:nvSpPr>
+        <p:spPr>
+          <a:xfrm>
+            <a:off x="731520" y="1097280"/>
+            <a:ext cx="7772400" cy="457200"/>
+          </a:xfrm>
+          <a:prstGeom prst="rect">
+            <a:avLst/>
+          </a:prstGeom>
+          <a:noFill/>
+        </p:spPr>
+        <p:txBody>
+          <a:bodyPr wrap="none">
+            <a:spAutoFit/>
+          </a:bodyPr>
+          <a:lstStyle/>
+          <a:p>
+            <a:pPr>
+              <a:defRPr sz="1400">
+                <a:solidFill>
+                  <a:srgbClr val="8899A6"/>
+                </a:solidFill>
+              </a:defRPr>
+            </a:pPr>
+            <a:r>
+              <a:t>Planned capabilities and long-term vision</a:t>
+            </a:r>
+          </a:p>
+        </p:txBody>
+      </p:sp>
+      <p:sp>
+        <p:nvSpPr>
+          <p:cNvPr id="5" name="TextBox 4"/>
+          <p:cNvSpPr txBox="1"/>
+          <p:nvPr/>
+        </p:nvSpPr>
+        <p:spPr>
+          <a:xfrm>
+            <a:off x="731520" y="1737360"/>
+            <a:ext cx="7680960" cy="4572000"/>
+          </a:xfrm>
+          <a:prstGeom prst="rect">
+            <a:avLst/>
+          </a:prstGeom>
+          <a:noFill/>
+        </p:spPr>
+        <p:txBody>
+          <a:bodyPr wrap="square">
+            <a:spAutoFit/>
+          </a:bodyPr>
+          <a:lstStyle/>
+          <a:p>
+            <a:pPr>
+              <a:spcBef>
+                <a:spcPts val="1400"/>
+              </a:spcBef>
+              <a:defRPr sz="1600" b="1">
+                <a:solidFill>
+                  <a:srgbClr val="FFFFFF"/>
+                </a:solidFill>
+              </a:defRPr>
+            </a:pPr>
+            <a:r>
+              <a:t>v2.1 (Near-Term)</a:t>
+            </a:r>
+          </a:p>
+          <a:p>
+            <a:pPr>
+              <a:spcBef>
+                <a:spcPts val="600"/>
+              </a:spcBef>
+              <a:defRPr sz="1300">
+                <a:solidFill>
+                  <a:srgbClr val="CCDDEE"/>
+                </a:solidFill>
+              </a:defRPr>
+            </a:pPr>
+            <a:r>
+              <a:t>ML-based anomaly detection (unsupervised clustering)</a:t>
+            </a:r>
+          </a:p>
+          <a:p>
+            <a:pPr>
+              <a:spcBef>
+                <a:spcPts val="600"/>
+              </a:spcBef>
+              <a:defRPr sz="1300">
+                <a:solidFill>
+                  <a:srgbClr val="CCDDEE"/>
+                </a:solidFill>
+              </a:defRPr>
+            </a:pPr>
+            <a:r>
+              <a:t>DBC file import for automatic threshold calibration</a:t>
+            </a:r>
+          </a:p>
+          <a:p>
+            <a:pPr>
+              <a:spcBef>
+                <a:spcPts val="600"/>
+              </a:spcBef>
+              <a:defRPr sz="1300">
+                <a:solidFill>
+                  <a:srgbClr val="CCDDEE"/>
+                </a:solidFill>
+              </a:defRPr>
+            </a:pPr>
+            <a:r>
+              <a:t>CAN-FD support (64-byte payloads)</a:t>
+            </a:r>
+          </a:p>
+          <a:p>
+            <a:pPr>
+              <a:spcBef>
+                <a:spcPts val="400"/>
+              </a:spcBef>
+            </a:pPr>
+          </a:p>
+          <a:p>
+            <a:pPr>
+              <a:spcBef>
+                <a:spcPts val="1400"/>
+              </a:spcBef>
+              <a:defRPr sz="1600" b="1">
+                <a:solidFill>
+                  <a:srgbClr val="FFFFFF"/>
+                </a:solidFill>
+              </a:defRPr>
+            </a:pPr>
+            <a:r>
+              <a:t>v3.0 (Mid-Term)</a:t>
+            </a:r>
+          </a:p>
+          <a:p>
+            <a:pPr>
+              <a:spcBef>
+                <a:spcPts val="600"/>
+              </a:spcBef>
+              <a:defRPr sz="1300">
+                <a:solidFill>
+                  <a:srgbClr val="CCDDEE"/>
+                </a:solidFill>
+              </a:defRPr>
+            </a:pPr>
+            <a:r>
+              <a:t>Real-time monitoring via USB-CAN (WebUSB API)</a:t>
+            </a:r>
+          </a:p>
+          <a:p>
+            <a:pPr>
+              <a:spcBef>
+                <a:spcPts val="600"/>
+              </a:spcBef>
+              <a:defRPr sz="1300">
+                <a:solidFill>
+                  <a:srgbClr val="CCDDEE"/>
+                </a:solidFill>
+              </a:defRPr>
+            </a:pPr>
+            <a:r>
+              <a:t>AUTOSAR SecOC validation module</a:t>
+            </a:r>
+          </a:p>
+          <a:p>
+            <a:pPr>
+              <a:spcBef>
+                <a:spcPts val="600"/>
+              </a:spcBef>
+              <a:defRPr sz="1300">
+                <a:solidFill>
+                  <a:srgbClr val="CCDDEE"/>
+                </a:solidFill>
+              </a:defRPr>
+            </a:pPr>
+            <a:r>
+              <a:t>DTC database integration</a:t>
+            </a:r>
+          </a:p>
+          <a:p>
+            <a:pPr>
+              <a:spcBef>
+                <a:spcPts val="400"/>
+              </a:spcBef>
+            </a:pPr>
+          </a:p>
+          <a:p>
+            <a:pPr>
+              <a:spcBef>
+                <a:spcPts val="1400"/>
+              </a:spcBef>
+              <a:defRPr sz="1600" b="1">
+                <a:solidFill>
+                  <a:srgbClr val="FFFFFF"/>
+                </a:solidFill>
+              </a:defRPr>
+            </a:pPr>
+            <a:r>
+              <a:t>Long-Term Vision</a:t>
+            </a:r>
+          </a:p>
+          <a:p>
+            <a:pPr>
+              <a:spcBef>
+                <a:spcPts val="600"/>
+              </a:spcBef>
+              <a:defRPr sz="1300">
+                <a:solidFill>
+                  <a:srgbClr val="CCDDEE"/>
+                </a:solidFill>
+              </a:defRPr>
+            </a:pPr>
+            <a:r>
+              <a:t>Multi-bus correlation (CAN, LIN, FlexRay, Automotive Ethernet)</a:t>
+            </a:r>
+          </a:p>
+          <a:p>
+            <a:pPr>
+              <a:spcBef>
+                <a:spcPts val="600"/>
+              </a:spcBef>
+              <a:defRPr sz="1300">
+                <a:solidFill>
+                  <a:srgbClr val="CCDDEE"/>
+                </a:solidFill>
+              </a:defRPr>
+            </a:pPr>
+            <a:r>
+              <a:t>Fleet-wide threat intelligence platform</a:t>
+            </a:r>
+          </a:p>
+          <a:p>
+            <a:pPr>
+              <a:spcBef>
+                <a:spcPts val="600"/>
+              </a:spcBef>
+              <a:defRPr sz="1300">
+                <a:solidFill>
+                  <a:srgbClr val="CCDDEE"/>
+                </a:solidFill>
+              </a:defRPr>
+            </a:pPr>
+            <a:r>
+              <a:t>ISO/SAE 21434 compliance automated reporting</a:t>
+            </a:r>
+          </a:p>
+          <a:p>
+            <a:pPr>
+              <a:spcBef>
+                <a:spcPts val="600"/>
+              </a:spcBef>
+              <a:defRPr sz="1300">
+                <a:solidFill>
+                  <a:srgbClr val="CCDDEE"/>
+                </a:solidFill>
+              </a:defRPr>
+            </a:pPr>
+            <a:r>
+              <a:t>Automated penetration testing framework</a:t>
+            </a:r>
+          </a:p>
+          <a:p>
+            <a:pPr>
+              <a:spcBef>
+                <a:spcPts val="400"/>
+              </a:spcBef>
+            </a:pPr>
+          </a:p>
+          <a:p>
+            <a:pPr>
+              <a:spcBef>
+                <a:spcPts val="1400"/>
+              </a:spcBef>
+              <a:defRPr sz="1600" b="1">
+                <a:solidFill>
+                  <a:srgbClr val="FFFFFF"/>
+                </a:solidFill>
+              </a:defRPr>
+            </a:pPr>
+            <a:r>
+              <a:t>Fully open, no vendor lock-in, zero licensing fees</a:t>
+            </a:r>
+          </a:p>
+        </p:txBody>
+      </p:sp>
+      <p:sp>
+        <p:nvSpPr>
+          <p:cNvPr id="6" name="Rectangle 5"/>
+          <p:cNvSpPr/>
+          <p:nvPr/>
+        </p:nvSpPr>
+        <p:spPr>
+          <a:xfrm>
+            <a:off x="0" y="6720840"/>
+            <a:ext cx="9144000" cy="137160"/>
+          </a:xfrm>
+          <a:prstGeom prst="rect">
+            <a:avLst/>
+          </a:prstGeom>
+          <a:solidFill>
+            <a:srgbClr val="0056B3"/>
+          </a:solidFill>
+          <a:ln>
+            <a:noFill/>
+          </a:ln>
+        </p:spPr>
+        <p:style>
+          <a:lnRef idx="1">
+            <a:schemeClr val="accent1"/>
+          </a:lnRef>
+          <a:fillRef idx="3">
+            <a:schemeClr val="accent1"/>
+          </a:fillRef>
+          <a:effectRef idx="2">
+            <a:schemeClr val="accent1"/>
+          </a:effectRef>
+          <a:fontRef idx="minor">
+            <a:schemeClr val="lt1"/>
+          </a:fontRef>
+        </p:style>
+        <p:txBody>
+          <a:bodyPr rtlCol="0" anchor="ctr"/>
+          <a:lstStyle/>
+          <a:p>
+            <a:pPr algn="ctr"/>
+          </a:p>
+        </p:txBody>
+      </p:sp>
+    </p:spTree>
+  </p:cSld>
+  <p:clrMapOvr>
+    <a:masterClrMapping/>
+  </p:clrMapOvr>
+</p:sld>
+</file>
+
+<file path=ppt/slides/slide9.xml><?xml version="1.0" encoding="utf-8"?>
+<p:sld xmlns:a="http://schemas.openxmlformats.org/drawingml/2006/main" xmlns:p="http://schemas.openxmlformats.org/presentationml/2006/main" xmlns:r="http://schemas.openxmlformats.org/officeDocument/2006/relationships">
+  <p:cSld>
+    <p:bg>
+      <p:bgPr>
+        <a:solidFill>
+          <a:srgbClr val="0A1628"/>
+        </a:solidFill>
+        <a:effectLst/>
+      </p:bgPr>
+    </p:bg>
+    <p:spTree>
+      <p:nvGrpSpPr>
+        <p:cNvPr id="1" name=""/>
+        <p:cNvGrpSpPr/>
+        <p:nvPr/>
+      </p:nvGrpSpPr>
+      <p:grpSpPr/>
+      <p:sp>
+        <p:nvSpPr>
+          <p:cNvPr id="2" name="Rectangle 1"/>
+          <p:cNvSpPr/>
+          <p:nvPr/>
+        </p:nvSpPr>
+        <p:spPr>
+          <a:xfrm>
+            <a:off x="0" y="0"/>
+            <a:ext cx="9144000" cy="91440"/>
+          </a:xfrm>
+          <a:prstGeom prst="rect">
+            <a:avLst/>
+          </a:prstGeom>
+          <a:solidFill>
+            <a:srgbClr val="00D4FF"/>
+          </a:solidFill>
+          <a:ln>
+            <a:noFill/>
+          </a:ln>
+        </p:spPr>
+        <p:style>
+          <a:lnRef idx="1">
+            <a:schemeClr val="accent1"/>
+          </a:lnRef>
+          <a:fillRef idx="3">
+            <a:schemeClr val="accent1"/>
+          </a:fillRef>
+          <a:effectRef idx="2">
+            <a:schemeClr val="accent1"/>
+          </a:effectRef>
+          <a:fontRef idx="minor">
+            <a:schemeClr val="lt1"/>
+          </a:fontRef>
+        </p:style>
+        <p:txBody>
+          <a:bodyPr rtlCol="0" anchor="ctr"/>
+          <a:lstStyle/>
+          <a:p>
+            <a:pPr algn="ctr"/>
+          </a:p>
+        </p:txBody>
+      </p:sp>
+      <p:sp>
+        <p:nvSpPr>
+          <p:cNvPr id="3" name="TextBox 2"/>
+          <p:cNvSpPr txBox="1"/>
+          <p:nvPr/>
+        </p:nvSpPr>
+        <p:spPr>
+          <a:xfrm>
+            <a:off x="914400" y="1371600"/>
+            <a:ext cx="7315200" cy="914400"/>
+          </a:xfrm>
+          <a:prstGeom prst="rect">
+            <a:avLst/>
+          </a:prstGeom>
+          <a:noFill/>
+        </p:spPr>
+        <p:txBody>
+          <a:bodyPr wrap="none">
+            <a:spAutoFit/>
+          </a:bodyPr>
+          <a:lstStyle/>
+          <a:p>
+            <a:pPr algn="ctr">
+              <a:defRPr sz="2800" b="1">
+                <a:solidFill>
+                  <a:srgbClr val="00D4FF"/>
+                </a:solidFill>
+              </a:defRPr>
+            </a:pPr>
+            <a:r>
+              <a:t>Ready to Secure Your CAN Network?</a:t>
+            </a:r>
+          </a:p>
+        </p:txBody>
+      </p:sp>
+      <p:sp>
+        <p:nvSpPr>
+          <p:cNvPr id="4" name="TextBox 3"/>
+          <p:cNvSpPr txBox="1"/>
+          <p:nvPr/>
+        </p:nvSpPr>
+        <p:spPr>
+          <a:xfrm>
+            <a:off x="1371600" y="2560320"/>
+            <a:ext cx="6400800" cy="3200400"/>
+          </a:xfrm>
+          <a:prstGeom prst="rect">
+            <a:avLst/>
+          </a:prstGeom>
+          <a:noFill/>
+        </p:spPr>
+        <p:txBody>
+          <a:bodyPr wrap="none">
+            <a:spAutoFit/>
+          </a:bodyPr>
+          <a:lstStyle/>
+          <a:p>
+            <a:pPr>
+              <a:spcBef>
+                <a:spcPts val="1200"/>
+              </a:spcBef>
+              <a:defRPr sz="1500">
+                <a:solidFill>
+                  <a:srgbClr val="E8F4FD"/>
+                </a:solidFill>
+              </a:defRPr>
+            </a:pPr>
+            <a:r>
+              <a:t>✅  Zero installation — just open the HTML file</a:t>
+            </a:r>
+          </a:p>
+          <a:p>
+            <a:pPr>
+              <a:spcBef>
+                <a:spcPts val="1200"/>
+              </a:spcBef>
+              <a:defRPr sz="1500">
+                <a:solidFill>
+                  <a:srgbClr val="E8F4FD"/>
+                </a:solidFill>
+              </a:defRPr>
+            </a:pPr>
+            <a:r>
+              <a:t>✅  100% offline — data never leaves the machine</a:t>
+            </a:r>
+          </a:p>
+          <a:p>
+            <a:pPr>
+              <a:spcBef>
+                <a:spcPts val="1200"/>
+              </a:spcBef>
+              <a:defRPr sz="1500">
+                <a:solidFill>
+                  <a:srgbClr val="E8F4FD"/>
+                </a:solidFill>
+              </a:defRPr>
+            </a:pPr>
+            <a:r>
+              <a:t>✅  Sub-second analysis — thousands of messages instantly</a:t>
+            </a:r>
+          </a:p>
+          <a:p>
+            <a:pPr>
+              <a:spcBef>
+                <a:spcPts val="1200"/>
+              </a:spcBef>
+              <a:defRPr sz="1500">
+                <a:solidFill>
+                  <a:srgbClr val="E8F4FD"/>
+                </a:solidFill>
+              </a:defRPr>
+            </a:pPr>
+            <a:r>
+              <a:t>✅  Professional reporting — CSV, JSON, TXT, PDF export</a:t>
+            </a:r>
+          </a:p>
+          <a:p>
+            <a:pPr>
+              <a:spcBef>
+                <a:spcPts val="1200"/>
+              </a:spcBef>
+              <a:defRPr sz="1500">
+                <a:solidFill>
+                  <a:srgbClr val="E8F4FD"/>
+                </a:solidFill>
+              </a:defRPr>
+            </a:pPr>
+            <a:r>
+              <a:t>✅  10 test scenarios — start analyzing immediately</a:t>
+            </a:r>
+          </a:p>
+          <a:p>
+            <a:pPr>
+              <a:spcBef>
+                <a:spcPts val="1200"/>
+              </a:spcBef>
+              <a:defRPr sz="1500">
+                <a:solidFill>
+                  <a:srgbClr val="E8F4FD"/>
+                </a:solidFill>
+              </a:defRPr>
+            </a:pPr>
+            <a:r>
+              <a:t>✅  Configurable — adapts to any vehicle architecture</a:t>
+            </a:r>
+          </a:p>
+          <a:p>
+            <a:pPr>
+              <a:spcBef>
+                <a:spcPts val="1200"/>
+              </a:spcBef>
+              <a:defRPr sz="1500">
+                <a:solidFill>
+                  <a:srgbClr val="E8F4FD"/>
+                </a:solidFill>
+              </a:defRPr>
+            </a:pPr>
+            <a:r>
+              <a:t>✅  Smart diagnostics — automated recommendations</a:t>
+            </a:r>
+          </a:p>
+        </p:txBody>
+      </p:sp>
+      <p:sp>
+        <p:nvSpPr>
+          <p:cNvPr id="5" name="TextBox 4"/>
+          <p:cNvSpPr txBox="1"/>
+          <p:nvPr/>
+        </p:nvSpPr>
+        <p:spPr>
+          <a:xfrm>
+            <a:off x="1371600" y="5760720"/>
+            <a:ext cx="6400800" cy="548640"/>
+          </a:xfrm>
+          <a:prstGeom prst="rect">
+            <a:avLst/>
+          </a:prstGeom>
+          <a:noFill/>
+        </p:spPr>
+        <p:txBody>
+          <a:bodyPr wrap="none">
+            <a:spAutoFit/>
+          </a:bodyPr>
+          <a:lstStyle/>
+          <a:p>
+            <a:pPr algn="ctr">
+              <a:defRPr sz="1400" b="1">
+                <a:solidFill>
+                  <a:srgbClr val="00D4FF"/>
+                </a:solidFill>
+              </a:defRPr>
+            </a:pPr>
+            <a:r>
+              <a:t>Open CAN_Spoofing_Diagnostic_Tool.html → Load test data → Analyze</a:t>
+            </a:r>
+          </a:p>
+        </p:txBody>
+      </p:sp>
+      <p:sp>
+        <p:nvSpPr>
+          <p:cNvPr id="6" name="Rectangle 5"/>
+          <p:cNvSpPr/>
+          <p:nvPr/>
+        </p:nvSpPr>
+        <p:spPr>
+          <a:xfrm>
+            <a:off x="0" y="6720840"/>
+            <a:ext cx="9144000" cy="137160"/>
+          </a:xfrm>
+          <a:prstGeom prst="rect">
+            <a:avLst/>
+          </a:prstGeom>
+          <a:solidFill>
+            <a:srgbClr val="0056B3"/>
+          </a:solidFill>
+          <a:ln>
+            <a:noFill/>
+          </a:ln>
+        </p:spPr>
+        <p:style>
+          <a:lnRef idx="1">
+            <a:schemeClr val="accent1"/>
+          </a:lnRef>
+          <a:fillRef idx="3">
+            <a:schemeClr val="accent1"/>
+          </a:fillRef>
+          <a:effectRef idx="2">
+            <a:schemeClr val="accent1"/>
+          </a:effectRef>
+          <a:fontRef idx="minor">
+            <a:schemeClr val="lt1"/>
+          </a:fontRef>
+        </p:style>
+        <p:txBody>
+          <a:bodyPr rtlCol="0" anchor="ctr"/>
+          <a:lstStyle/>
+          <a:p>
+            <a:pPr algn="ctr"/>
           </a:p>
         </p:txBody>
       </p:sp>

</xml_diff>